<commit_message>
Ajoute les acquis de la regression multiple
MEMO : pieges get_dummies et drop_duplicates, section regression multiple (R² d'entrainement, reference naive, hierarchie polynomiale), dix entrees de methode. Slides : six nouvelles sur la fuite, l'unite d'observation, la colinearite et les residus.
</commit_message>
<xml_diff>
--- a/memo-machine-learning.pptx
+++ b/memo-machine-learning.pptx
@@ -18,6 +18,12 @@
     <p:sldId id="266" r:id="rId12"/>
     <p:sldId id="267" r:id="rId13"/>
     <p:sldId id="268" r:id="rId14"/>
+    <p:sldId id="271" r:id="rId22"/>
+    <p:sldId id="272" r:id="rId23"/>
+    <p:sldId id="273" r:id="rId24"/>
+    <p:sldId id="274" r:id="rId25"/>
+    <p:sldId id="275" r:id="rId26"/>
+    <p:sldId id="276" r:id="rId27"/>
     <p:sldId id="269" r:id="rId15"/>
     <p:sldId id="270" r:id="rId16"/>
   </p:sldIdLst>
@@ -5879,7 +5885,2225 @@
                 <a:ea typeface="Calibri" pitchFamily="34" charset="-122"/>
                 <a:cs typeface="Calibri" pitchFamily="34" charset="-120"/>
               </a:rPr>
-              <a:t>Prochaine étape : régression multiple — plusieurs variables, et la normalisation devient obligatoire.</a:t>
+              <a:t>Prochaine étape : classification — une cible binaire, une autre fonction de coût, d'autres métriques que le R².</a:t>
+            </a:r>
+            <a:endParaRPr lang="en-US" sz="1250" dirty="0"/>
+          </a:p>
+        </p:txBody>
+      </p:sp>
+    </p:spTree>
+  </p:cSld>
+  <p:clrMapOvr>
+    <a:masterClrMapping/>
+  </p:clrMapOvr>
+</p:sld>
+</file>
+
+<file path=ppt/slides/slide16.xml><?xml version="1.0" encoding="utf-8"?>
+<p:sld xmlns:a="http://schemas.openxmlformats.org/drawingml/2006/main" xmlns:r="http://schemas.openxmlformats.org/officeDocument/2006/relationships" xmlns:p="http://schemas.openxmlformats.org/presentationml/2006/main">
+  <p:cSld name="Slide 8">
+    <p:spTree>
+      <p:nvGrpSpPr>
+        <p:cNvPr id="1" name=""/>
+        <p:cNvGrpSpPr/>
+        <p:nvPr/>
+      </p:nvGrpSpPr>
+      <p:grpSpPr>
+        <a:xfrm>
+          <a:off x="0" y="0"/>
+          <a:ext cx="0" cy="0"/>
+          <a:chOff x="0" y="0"/>
+          <a:chExt cx="0" cy="0"/>
+        </a:xfrm>
+      </p:grpSpPr>
+      <p:sp>
+        <p:nvSpPr>
+          <p:cNvPr id="2" name="Text 0"/>
+          <p:cNvSpPr/>
+          <p:nvPr/>
+        </p:nvSpPr>
+        <p:spPr>
+          <a:xfrm>
+            <a:off x="640080" y="384048"/>
+            <a:ext cx="10881360" cy="685800"/>
+          </a:xfrm>
+          <a:prstGeom prst="rect">
+            <a:avLst/>
+          </a:prstGeom>
+          <a:noFill/>
+          <a:ln/>
+        </p:spPr>
+        <p:txBody>
+          <a:bodyPr wrap="square" lIns="0" tIns="0" rIns="0" bIns="0" rtlCol="0" anchor="ctr"/>
+          <a:lstStyle/>
+          <a:p>
+            <a:pPr indent="0" marL="0">
+              <a:buNone/>
+            </a:pPr>
+            <a:r>
+              <a:rPr lang="en-US" sz="3400" b="1" dirty="0">
+                <a:solidFill>
+                  <a:srgbClr val="1F2A1F"/>
+                </a:solidFill>
+                <a:latin typeface="Cambria" pitchFamily="34" charset="0"/>
+                <a:ea typeface="Cambria" pitchFamily="34" charset="-122"/>
+                <a:cs typeface="Cambria" pitchFamily="34" charset="-120"/>
+              </a:rPr>
+              <a:t>Une variable trop bonne pour être vraie</a:t>
+            </a:r>
+            <a:endParaRPr lang="en-US" sz="3400" dirty="0"/>
+          </a:p>
+        </p:txBody>
+      </p:sp>
+      <p:sp>
+        <p:nvSpPr>
+          <p:cNvPr id="3" name="Text 1"/>
+          <p:cNvSpPr/>
+          <p:nvPr/>
+        </p:nvSpPr>
+        <p:spPr>
+          <a:xfrm>
+            <a:off x="640080" y="1078992"/>
+            <a:ext cx="10881360" cy="384048"/>
+          </a:xfrm>
+          <a:prstGeom prst="rect">
+            <a:avLst/>
+          </a:prstGeom>
+          <a:noFill/>
+          <a:ln/>
+        </p:spPr>
+        <p:txBody>
+          <a:bodyPr wrap="square" lIns="0" tIns="0" rIns="0" bIns="0" rtlCol="0" anchor="ctr"/>
+          <a:lstStyle/>
+          <a:p>
+            <a:pPr indent="0" marL="0">
+              <a:buNone/>
+            </a:pPr>
+            <a:r>
+              <a:rPr lang="en-US" sz="1400" i="1" dirty="0">
+                <a:solidFill>
+                  <a:srgbClr val="5E6E5E"/>
+                </a:solidFill>
+                <a:latin typeface="Calibri" pitchFamily="34" charset="0"/>
+                <a:ea typeface="Calibri" pitchFamily="34" charset="-122"/>
+                <a:cs typeface="Calibri" pitchFamily="34" charset="-120"/>
+              </a:rPr>
+              <a:t>Un R² de 0,999 n'est pas une bonne nouvelle</a:t>
+            </a:r>
+            <a:endParaRPr lang="en-US" sz="1400" dirty="0"/>
+          </a:p>
+        </p:txBody>
+      </p:sp>
+      <p:sp>
+        <p:nvSpPr>
+          <p:cNvPr id="4" name="Shape 2"/>
+          <p:cNvSpPr/>
+          <p:nvPr/>
+        </p:nvSpPr>
+        <p:spPr>
+          <a:xfrm>
+            <a:off x="640080" y="1737360"/>
+            <a:ext cx="5166360" cy="2834640"/>
+          </a:xfrm>
+          <a:prstGeom prst="roundRect">
+            <a:avLst>
+              <a:gd name="adj" fmla="val 2581"/>
+            </a:avLst>
+          </a:prstGeom>
+          <a:solidFill>
+            <a:srgbClr val="EDF2E6"/>
+          </a:solidFill>
+          <a:ln w="12700">
+            <a:solidFill>
+              <a:srgbClr val="EDF2E6"/>
+            </a:solidFill>
+            <a:prstDash val="solid"/>
+          </a:ln>
+        </p:spPr>
+      </p:sp>
+      <p:sp>
+        <p:nvSpPr>
+          <p:cNvPr id="5" name="Text 3"/>
+          <p:cNvSpPr/>
+          <p:nvPr/>
+        </p:nvSpPr>
+        <p:spPr>
+          <a:xfrm>
+            <a:off x="960120" y="1920240"/>
+            <a:ext cx="4389120" cy="310896"/>
+          </a:xfrm>
+          <a:prstGeom prst="rect">
+            <a:avLst/>
+          </a:prstGeom>
+          <a:noFill/>
+          <a:ln/>
+        </p:spPr>
+        <p:txBody>
+          <a:bodyPr wrap="square" lIns="0" tIns="0" rIns="0" bIns="0" rtlCol="0" anchor="ctr"/>
+          <a:lstStyle/>
+          <a:p>
+            <a:pPr indent="0" marL="0">
+              <a:buNone/>
+            </a:pPr>
+            <a:r>
+              <a:rPr lang="en-US" sz="1700" b="1" dirty="0">
+                <a:solidFill>
+                  <a:srgbClr val="2C5F2D"/>
+                </a:solidFill>
+                <a:latin typeface="Cambria" pitchFamily="34" charset="0"/>
+                <a:ea typeface="Cambria" pitchFamily="34" charset="-122"/>
+                <a:cs typeface="Cambria" pitchFamily="34" charset="-120"/>
+              </a:rPr>
+              <a:t>Fuite directe</a:t>
+            </a:r>
+            <a:endParaRPr lang="en-US" sz="1700" dirty="0"/>
+          </a:p>
+        </p:txBody>
+      </p:sp>
+      <p:sp>
+        <p:nvSpPr>
+          <p:cNvPr id="6" name="Text 4"/>
+          <p:cNvSpPr/>
+          <p:nvPr/>
+        </p:nvSpPr>
+        <p:spPr>
+          <a:xfrm>
+            <a:off x="960120" y="2377440"/>
+            <a:ext cx="4572000" cy="2011680"/>
+          </a:xfrm>
+          <a:prstGeom prst="rect">
+            <a:avLst/>
+          </a:prstGeom>
+          <a:noFill/>
+          <a:ln/>
+        </p:spPr>
+        <p:txBody>
+          <a:bodyPr wrap="square" lIns="0" tIns="0" rIns="0" bIns="0" rtlCol="0" anchor="t"/>
+          <a:lstStyle/>
+          <a:p>
+            <a:pPr indent="0" marL="0">
+              <a:lnSpc>
+                <a:spcPct val="115000"/>
+              </a:lnSpc>
+              <a:buNone/>
+            </a:pPr>
+            <a:r>
+              <a:rPr lang="en-US" sz="1200" dirty="0">
+                <a:solidFill>
+                  <a:srgbClr val="1F2A1F"/>
+                </a:solidFill>
+                <a:latin typeface="Calibri" pitchFamily="34" charset="0"/>
+                <a:ea typeface="Calibri" pitchFamily="34" charset="-122"/>
+                <a:cs typeface="Calibri" pitchFamily="34" charset="-120"/>
+              </a:rPr>
+              <a:t>Le CO₂ homologué est calculé à partir de la consommation : leur rapport est une constante.</a:t>
+            </a:r>
+            <a:endParaRPr lang="en-US" sz="1200" dirty="0"/>
+          </a:p>
+          <a:p>
+            <a:pPr indent="0" marL="0">
+              <a:lnSpc>
+                <a:spcPct val="115000"/>
+              </a:lnSpc>
+              <a:buNone/>
+            </a:pPr>
+            <a:endParaRPr lang="en-US" sz="1200" dirty="0"/>
+          </a:p>
+          <a:p>
+            <a:pPr indent="0" marL="0">
+              <a:lnSpc>
+                <a:spcPct val="115000"/>
+              </a:lnSpc>
+              <a:buNone/>
+            </a:pPr>
+            <a:r>
+              <a:rPr lang="en-US" sz="1200" dirty="0">
+                <a:solidFill>
+                  <a:srgbClr val="1F2A1F"/>
+                </a:solidFill>
+                <a:latin typeface="Calibri" pitchFamily="34" charset="0"/>
+                <a:ea typeface="Calibri" pitchFamily="34" charset="-122"/>
+                <a:cs typeface="Calibri" pitchFamily="34" charset="-120"/>
+              </a:rPr>
+              <a:t>• R² = 0,999 et MAE = 0,9 g/km</a:t>
+            </a:r>
+            <a:endParaRPr lang="en-US" sz="1200" dirty="0"/>
+          </a:p>
+          <a:p>
+            <a:pPr indent="0" marL="0">
+              <a:lnSpc>
+                <a:spcPct val="115000"/>
+              </a:lnSpc>
+              <a:buNone/>
+            </a:pPr>
+            <a:r>
+              <a:rPr lang="en-US" sz="1200" dirty="0">
+                <a:solidFill>
+                  <a:srgbClr val="1F2A1F"/>
+                </a:solidFill>
+                <a:latin typeface="Calibri" pitchFamily="34" charset="0"/>
+                <a:ea typeface="Calibri" pitchFamily="34" charset="-122"/>
+                <a:cs typeface="Calibri" pitchFamily="34" charset="-120"/>
+              </a:rPr>
+              <a:t>• Coefficient appris : 2,64 kg de CO₂ par litre</a:t>
+            </a:r>
+            <a:endParaRPr lang="en-US" sz="1200" dirty="0"/>
+          </a:p>
+          <a:p>
+            <a:pPr indent="0" marL="0">
+              <a:lnSpc>
+                <a:spcPct val="115000"/>
+              </a:lnSpc>
+              <a:buNone/>
+            </a:pPr>
+            <a:endParaRPr lang="en-US" sz="1200" dirty="0"/>
+          </a:p>
+          <a:p>
+            <a:pPr indent="0" marL="0">
+              <a:lnSpc>
+                <a:spcPct val="115000"/>
+              </a:lnSpc>
+              <a:buNone/>
+            </a:pPr>
+            <a:r>
+              <a:rPr lang="en-US" sz="1200" dirty="0">
+                <a:solidFill>
+                  <a:srgbClr val="1F2A1F"/>
+                </a:solidFill>
+                <a:latin typeface="Calibri" pitchFamily="34" charset="0"/>
+                <a:ea typeface="Calibri" pitchFamily="34" charset="-122"/>
+                <a:cs typeface="Calibri" pitchFamily="34" charset="-120"/>
+              </a:rPr>
+              <a:t>Le facteur d'émission du gazole — une constante physique, pas un paramètre.</a:t>
+            </a:r>
+            <a:endParaRPr lang="en-US" sz="1200" dirty="0"/>
+          </a:p>
+        </p:txBody>
+      </p:sp>
+      <p:sp>
+        <p:nvSpPr>
+          <p:cNvPr id="7" name="Shape 5"/>
+          <p:cNvSpPr/>
+          <p:nvPr/>
+        </p:nvSpPr>
+        <p:spPr>
+          <a:xfrm>
+            <a:off x="6355080" y="1737360"/>
+            <a:ext cx="5166360" cy="2834640"/>
+          </a:xfrm>
+          <a:prstGeom prst="roundRect">
+            <a:avLst>
+              <a:gd name="adj" fmla="val 2581"/>
+            </a:avLst>
+          </a:prstGeom>
+          <a:solidFill>
+            <a:srgbClr val="EDF2E6"/>
+          </a:solidFill>
+          <a:ln w="12700">
+            <a:solidFill>
+              <a:srgbClr val="EDF2E6"/>
+            </a:solidFill>
+            <a:prstDash val="solid"/>
+          </a:ln>
+        </p:spPr>
+      </p:sp>
+      <p:sp>
+        <p:nvSpPr>
+          <p:cNvPr id="8" name="Text 6"/>
+          <p:cNvSpPr/>
+          <p:nvPr/>
+        </p:nvSpPr>
+        <p:spPr>
+          <a:xfrm>
+            <a:off x="6675120" y="1920240"/>
+            <a:ext cx="4389120" cy="310896"/>
+          </a:xfrm>
+          <a:prstGeom prst="rect">
+            <a:avLst/>
+          </a:prstGeom>
+          <a:noFill/>
+          <a:ln/>
+        </p:spPr>
+        <p:txBody>
+          <a:bodyPr wrap="square" lIns="0" tIns="0" rIns="0" bIns="0" rtlCol="0" anchor="ctr"/>
+          <a:lstStyle/>
+          <a:p>
+            <a:pPr indent="0" marL="0">
+              <a:buNone/>
+            </a:pPr>
+            <a:r>
+              <a:rPr lang="en-US" sz="1700" b="1" dirty="0">
+                <a:solidFill>
+                  <a:srgbClr val="5E6E5E"/>
+                </a:solidFill>
+                <a:latin typeface="Cambria" pitchFamily="34" charset="0"/>
+                <a:ea typeface="Cambria" pitchFamily="34" charset="-122"/>
+                <a:cs typeface="Cambria" pitchFamily="34" charset="-120"/>
+              </a:rPr>
+              <a:t>Fuite par formule</a:t>
+            </a:r>
+            <a:endParaRPr lang="en-US" sz="1700" dirty="0"/>
+          </a:p>
+        </p:txBody>
+      </p:sp>
+      <p:sp>
+        <p:nvSpPr>
+          <p:cNvPr id="9" name="Text 7"/>
+          <p:cNvSpPr/>
+          <p:nvPr/>
+        </p:nvSpPr>
+        <p:spPr>
+          <a:xfrm>
+            <a:off x="6675120" y="2377440"/>
+            <a:ext cx="4572000" cy="2011680"/>
+          </a:xfrm>
+          <a:prstGeom prst="rect">
+            <a:avLst/>
+          </a:prstGeom>
+          <a:noFill/>
+          <a:ln/>
+        </p:spPr>
+        <p:txBody>
+          <a:bodyPr wrap="square" lIns="0" tIns="0" rIns="0" bIns="0" rtlCol="0" anchor="t"/>
+          <a:lstStyle/>
+          <a:p>
+            <a:pPr indent="0" marL="0">
+              <a:lnSpc>
+                <a:spcPct val="115000"/>
+              </a:lnSpc>
+              <a:buNone/>
+            </a:pPr>
+            <a:r>
+              <a:rPr lang="en-US" sz="1200" dirty="0">
+                <a:solidFill>
+                  <a:srgbClr val="1F2A1F"/>
+                </a:solidFill>
+                <a:latin typeface="Calibri" pitchFamily="34" charset="0"/>
+                <a:ea typeface="Calibri" pitchFamily="34" charset="-122"/>
+                <a:cs typeface="Calibri" pitchFamily="34" charset="-120"/>
+              </a:rPr>
+              <a:t>La puissance administrative se calcule depuis 1998 par une formule qui contient le CO₂.</a:t>
+            </a:r>
+            <a:endParaRPr lang="en-US" sz="1200" dirty="0"/>
+          </a:p>
+          <a:p>
+            <a:pPr indent="0" marL="0">
+              <a:lnSpc>
+                <a:spcPct val="115000"/>
+              </a:lnSpc>
+              <a:buNone/>
+            </a:pPr>
+            <a:endParaRPr lang="en-US" sz="1200" dirty="0"/>
+          </a:p>
+          <a:p>
+            <a:pPr indent="0" marL="0">
+              <a:lnSpc>
+                <a:spcPct val="115000"/>
+              </a:lnSpc>
+              <a:buNone/>
+            </a:pPr>
+            <a:r>
+              <a:rPr lang="en-US" sz="1200" dirty="0">
+                <a:solidFill>
+                  <a:srgbClr val="1F2A1F"/>
+                </a:solidFill>
+                <a:latin typeface="Calibri" pitchFamily="34" charset="0"/>
+                <a:ea typeface="Calibri" pitchFamily="34" charset="-122"/>
+                <a:cs typeface="Calibri" pitchFamily="34" charset="-120"/>
+              </a:rPr>
+              <a:t>• Corrélation avec la cible : 0,708 seulement</a:t>
+            </a:r>
+            <a:endParaRPr lang="en-US" sz="1200" dirty="0"/>
+          </a:p>
+          <a:p>
+            <a:pPr indent="0" marL="0">
+              <a:lnSpc>
+                <a:spcPct val="115000"/>
+              </a:lnSpc>
+              <a:buNone/>
+            </a:pPr>
+            <a:r>
+              <a:rPr lang="en-US" sz="1200" dirty="0">
+                <a:solidFill>
+                  <a:srgbClr val="1F2A1F"/>
+                </a:solidFill>
+                <a:latin typeface="Calibri" pitchFamily="34" charset="0"/>
+                <a:ea typeface="Calibri" pitchFamily="34" charset="-122"/>
+                <a:cs typeface="Calibri" pitchFamily="34" charset="-120"/>
+              </a:rPr>
+              <a:t>• La formule reproduit 99,5 % des lignes</a:t>
+            </a:r>
+            <a:endParaRPr lang="en-US" sz="1200" dirty="0"/>
+          </a:p>
+          <a:p>
+            <a:pPr indent="0" marL="0">
+              <a:lnSpc>
+                <a:spcPct val="115000"/>
+              </a:lnSpc>
+              <a:buNone/>
+            </a:pPr>
+            <a:endParaRPr lang="en-US" sz="1200" dirty="0"/>
+          </a:p>
+          <a:p>
+            <a:pPr indent="0" marL="0">
+              <a:lnSpc>
+                <a:spcPct val="115000"/>
+              </a:lnSpc>
+              <a:buNone/>
+            </a:pPr>
+            <a:r>
+              <a:rPr lang="en-US" sz="1200" dirty="0">
+                <a:solidFill>
+                  <a:srgbClr val="1F2A1F"/>
+                </a:solidFill>
+                <a:latin typeface="Calibri" pitchFamily="34" charset="0"/>
+                <a:ea typeface="Calibri" pitchFamily="34" charset="-122"/>
+                <a:cs typeface="Calibri" pitchFamily="34" charset="-120"/>
+              </a:rPr>
+              <a:t>Une fuite non linéaire est invisible dans une matrice de corrélation.</a:t>
+            </a:r>
+            <a:endParaRPr lang="en-US" sz="1200" dirty="0"/>
+          </a:p>
+        </p:txBody>
+      </p:sp>
+      <p:sp>
+        <p:nvSpPr>
+          <p:cNvPr id="10" name="Shape 8"/>
+          <p:cNvSpPr/>
+          <p:nvPr/>
+        </p:nvSpPr>
+        <p:spPr>
+          <a:xfrm>
+            <a:off x="640080" y="4846320"/>
+            <a:ext cx="10881360" cy="914400"/>
+          </a:xfrm>
+          <a:prstGeom prst="roundRect">
+            <a:avLst>
+              <a:gd name="adj" fmla="val 8000"/>
+            </a:avLst>
+          </a:prstGeom>
+          <a:solidFill>
+            <a:srgbClr val="1A3A1C"/>
+          </a:solidFill>
+          <a:ln w="12700">
+            <a:solidFill>
+              <a:srgbClr val="1A3A1C"/>
+            </a:solidFill>
+            <a:prstDash val="solid"/>
+          </a:ln>
+        </p:spPr>
+      </p:sp>
+      <p:sp>
+        <p:nvSpPr>
+          <p:cNvPr id="11" name="Text 9"/>
+          <p:cNvSpPr/>
+          <p:nvPr/>
+        </p:nvSpPr>
+        <p:spPr>
+          <a:xfrm>
+            <a:off x="960120" y="5029200"/>
+            <a:ext cx="10241280" cy="548640"/>
+          </a:xfrm>
+          <a:prstGeom prst="rect">
+            <a:avLst/>
+          </a:prstGeom>
+          <a:noFill/>
+          <a:ln/>
+        </p:spPr>
+        <p:txBody>
+          <a:bodyPr wrap="square" lIns="0" tIns="0" rIns="0" bIns="0" rtlCol="0" anchor="ctr"/>
+          <a:lstStyle/>
+          <a:p>
+            <a:pPr indent="0" marL="0">
+              <a:buNone/>
+            </a:pPr>
+            <a:r>
+              <a:rPr lang="en-US" sz="1350" dirty="0">
+                <a:solidFill>
+                  <a:srgbClr val="FFFFFF"/>
+                </a:solidFill>
+                <a:latin typeface="Calibri" pitchFamily="34" charset="0"/>
+                <a:ea typeface="Calibri" pitchFamily="34" charset="-122"/>
+                <a:cs typeface="Calibri" pitchFamily="34" charset="-120"/>
+              </a:rPr>
+              <a:t>Le test : cette variable serait-elle connue avant la cible, en situation réelle ? Sinon, elle sort du modèle.</a:t>
+            </a:r>
+            <a:endParaRPr lang="en-US" sz="1350" dirty="0"/>
+          </a:p>
+        </p:txBody>
+      </p:sp>
+    </p:spTree>
+  </p:cSld>
+  <p:clrMapOvr>
+    <a:masterClrMapping/>
+  </p:clrMapOvr>
+</p:sld>
+</file>
+
+<file path=ppt/slides/slide17.xml><?xml version="1.0" encoding="utf-8"?>
+<p:sld xmlns:a="http://schemas.openxmlformats.org/drawingml/2006/main" xmlns:r="http://schemas.openxmlformats.org/officeDocument/2006/relationships" xmlns:p="http://schemas.openxmlformats.org/presentationml/2006/main">
+  <p:cSld name="Slide 11">
+    <p:spTree>
+      <p:nvGrpSpPr>
+        <p:cNvPr id="1" name=""/>
+        <p:cNvGrpSpPr/>
+        <p:nvPr/>
+      </p:nvGrpSpPr>
+      <p:grpSpPr>
+        <a:xfrm>
+          <a:off x="0" y="0"/>
+          <a:ext cx="0" cy="0"/>
+          <a:chOff x="0" y="0"/>
+          <a:chExt cx="0" cy="0"/>
+        </a:xfrm>
+      </p:grpSpPr>
+      <p:sp>
+        <p:nvSpPr>
+          <p:cNvPr id="2" name="Text 0"/>
+          <p:cNvSpPr/>
+          <p:nvPr/>
+        </p:nvSpPr>
+        <p:spPr>
+          <a:xfrm>
+            <a:off x="640080" y="384048"/>
+            <a:ext cx="10881360" cy="685800"/>
+          </a:xfrm>
+          <a:prstGeom prst="rect">
+            <a:avLst/>
+          </a:prstGeom>
+          <a:noFill/>
+          <a:ln/>
+        </p:spPr>
+        <p:txBody>
+          <a:bodyPr wrap="square" lIns="0" tIns="0" rIns="0" bIns="0" rtlCol="0" anchor="ctr"/>
+          <a:lstStyle/>
+          <a:p>
+            <a:pPr indent="0" marL="0">
+              <a:buNone/>
+            </a:pPr>
+            <a:r>
+              <a:rPr lang="en-US" sz="3400" b="1" dirty="0">
+                <a:solidFill>
+                  <a:srgbClr val="1F2A1F"/>
+                </a:solidFill>
+                <a:latin typeface="Cambria" pitchFamily="34" charset="0"/>
+                <a:ea typeface="Cambria" pitchFamily="34" charset="-122"/>
+                <a:cs typeface="Cambria" pitchFamily="34" charset="-120"/>
+              </a:rPr>
+              <a:t>Une ligne n'est pas une observation</a:t>
+            </a:r>
+            <a:endParaRPr lang="en-US" sz="3400" dirty="0"/>
+          </a:p>
+        </p:txBody>
+      </p:sp>
+      <p:sp>
+        <p:nvSpPr>
+          <p:cNvPr id="3" name="Text 1"/>
+          <p:cNvSpPr/>
+          <p:nvPr/>
+        </p:nvSpPr>
+        <p:spPr>
+          <a:xfrm>
+            <a:off x="640080" y="1078992"/>
+            <a:ext cx="10881360" cy="384048"/>
+          </a:xfrm>
+          <a:prstGeom prst="rect">
+            <a:avLst/>
+          </a:prstGeom>
+          <a:noFill/>
+          <a:ln/>
+        </p:spPr>
+        <p:txBody>
+          <a:bodyPr wrap="square" lIns="0" tIns="0" rIns="0" bIns="0" rtlCol="0" anchor="ctr"/>
+          <a:lstStyle/>
+          <a:p>
+            <a:pPr indent="0" marL="0">
+              <a:buNone/>
+            </a:pPr>
+            <a:r>
+              <a:rPr lang="en-US" sz="1400" i="1" dirty="0">
+                <a:solidFill>
+                  <a:srgbClr val="5E6E5E"/>
+                </a:solidFill>
+                <a:latin typeface="Calibri" pitchFamily="34" charset="0"/>
+                <a:ea typeface="Calibri" pitchFamily="34" charset="-122"/>
+                <a:cs typeface="Calibri" pitchFamily="34" charset="-120"/>
+              </a:rPr>
+              <a:t>Vérifier l'unité du fichier avant tout calcul</a:t>
+            </a:r>
+            <a:endParaRPr lang="en-US" sz="1400" dirty="0"/>
+          </a:p>
+        </p:txBody>
+      </p:sp>
+      <p:sp>
+        <p:nvSpPr>
+          <p:cNvPr id="4" name="Shape 2"/>
+          <p:cNvSpPr/>
+          <p:nvPr/>
+        </p:nvSpPr>
+        <p:spPr>
+          <a:xfrm>
+            <a:off x="640080" y="1737360"/>
+            <a:ext cx="5166360" cy="1828800"/>
+          </a:xfrm>
+          <a:prstGeom prst="roundRect">
+            <a:avLst>
+              <a:gd name="adj" fmla="val 4000"/>
+            </a:avLst>
+          </a:prstGeom>
+          <a:solidFill>
+            <a:srgbClr val="EDF2E6"/>
+          </a:solidFill>
+          <a:ln w="12700">
+            <a:solidFill>
+              <a:srgbClr val="EDF2E6"/>
+            </a:solidFill>
+            <a:prstDash val="solid"/>
+          </a:ln>
+        </p:spPr>
+      </p:sp>
+      <p:sp>
+        <p:nvSpPr>
+          <p:cNvPr id="5" name="Text 3"/>
+          <p:cNvSpPr/>
+          <p:nvPr/>
+        </p:nvSpPr>
+        <p:spPr>
+          <a:xfrm>
+            <a:off x="960120" y="1920240"/>
+            <a:ext cx="4389120" cy="310896"/>
+          </a:xfrm>
+          <a:prstGeom prst="rect">
+            <a:avLst/>
+          </a:prstGeom>
+          <a:noFill/>
+          <a:ln/>
+        </p:spPr>
+        <p:txBody>
+          <a:bodyPr wrap="square" lIns="0" tIns="0" rIns="0" bIns="0" rtlCol="0" anchor="ctr"/>
+          <a:lstStyle/>
+          <a:p>
+            <a:pPr indent="0" marL="0">
+              <a:buNone/>
+            </a:pPr>
+            <a:r>
+              <a:rPr lang="en-US" sz="1700" b="1" dirty="0">
+                <a:solidFill>
+                  <a:srgbClr val="5E6E5E"/>
+                </a:solidFill>
+                <a:latin typeface="Cambria" pitchFamily="34" charset="0"/>
+                <a:ea typeface="Cambria" pitchFamily="34" charset="-122"/>
+                <a:cs typeface="Cambria" pitchFamily="34" charset="-120"/>
+              </a:rPr>
+              <a:t>Ce que contient le fichier</a:t>
+            </a:r>
+            <a:endParaRPr lang="en-US" sz="1700" dirty="0"/>
+          </a:p>
+        </p:txBody>
+      </p:sp>
+      <p:sp>
+        <p:nvSpPr>
+          <p:cNvPr id="6" name="Text 4"/>
+          <p:cNvSpPr/>
+          <p:nvPr/>
+        </p:nvSpPr>
+        <p:spPr>
+          <a:xfrm>
+            <a:off x="960120" y="2377440"/>
+            <a:ext cx="4572000" cy="1005840"/>
+          </a:xfrm>
+          <a:prstGeom prst="rect">
+            <a:avLst/>
+          </a:prstGeom>
+          <a:noFill/>
+          <a:ln/>
+        </p:spPr>
+        <p:txBody>
+          <a:bodyPr wrap="square" lIns="0" tIns="0" rIns="0" bIns="0" rtlCol="0" anchor="t"/>
+          <a:lstStyle/>
+          <a:p>
+            <a:pPr indent="0" marL="0">
+              <a:lnSpc>
+                <a:spcPct val="115000"/>
+              </a:lnSpc>
+              <a:buNone/>
+            </a:pPr>
+            <a:r>
+              <a:rPr lang="en-US" sz="1200" dirty="0">
+                <a:solidFill>
+                  <a:srgbClr val="1F2A1F"/>
+                </a:solidFill>
+                <a:latin typeface="Calibri" pitchFamily="34" charset="0"/>
+                <a:ea typeface="Calibri" pitchFamily="34" charset="-122"/>
+                <a:cs typeface="Calibri" pitchFamily="34" charset="-120"/>
+              </a:rPr>
+              <a:t>Chaque véhicule est déclaré une fois par variante d'homologation : mêmes masse, puissance et CO₂, numéros de dossier différents. Rien ne signale la répétition.</a:t>
+            </a:r>
+            <a:endParaRPr lang="en-US" sz="1200" dirty="0"/>
+          </a:p>
+        </p:txBody>
+      </p:sp>
+      <p:sp>
+        <p:nvSpPr>
+          <p:cNvPr id="7" name="Shape 5"/>
+          <p:cNvSpPr/>
+          <p:nvPr/>
+        </p:nvSpPr>
+        <p:spPr>
+          <a:xfrm>
+            <a:off x="6355080" y="1737360"/>
+            <a:ext cx="5166360" cy="1828800"/>
+          </a:xfrm>
+          <a:prstGeom prst="roundRect">
+            <a:avLst>
+              <a:gd name="adj" fmla="val 4000"/>
+            </a:avLst>
+          </a:prstGeom>
+          <a:solidFill>
+            <a:srgbClr val="1A3A1C"/>
+          </a:solidFill>
+          <a:ln w="12700">
+            <a:solidFill>
+              <a:srgbClr val="1A3A1C"/>
+            </a:solidFill>
+            <a:prstDash val="solid"/>
+          </a:ln>
+        </p:spPr>
+      </p:sp>
+      <p:sp>
+        <p:nvSpPr>
+          <p:cNvPr id="8" name="Text 6"/>
+          <p:cNvSpPr/>
+          <p:nvPr/>
+        </p:nvSpPr>
+        <p:spPr>
+          <a:xfrm>
+            <a:off x="6675120" y="1920240"/>
+            <a:ext cx="4389120" cy="310896"/>
+          </a:xfrm>
+          <a:prstGeom prst="rect">
+            <a:avLst/>
+          </a:prstGeom>
+          <a:noFill/>
+          <a:ln/>
+        </p:spPr>
+        <p:txBody>
+          <a:bodyPr wrap="square" lIns="0" tIns="0" rIns="0" bIns="0" rtlCol="0" anchor="ctr"/>
+          <a:lstStyle/>
+          <a:p>
+            <a:pPr indent="0" marL="0">
+              <a:buNone/>
+            </a:pPr>
+            <a:r>
+              <a:rPr lang="en-US" sz="1700" b="1" dirty="0">
+                <a:solidFill>
+                  <a:srgbClr val="97BC62"/>
+                </a:solidFill>
+                <a:latin typeface="Cambria" pitchFamily="34" charset="0"/>
+                <a:ea typeface="Cambria" pitchFamily="34" charset="-122"/>
+                <a:cs typeface="Cambria" pitchFamily="34" charset="-120"/>
+              </a:rPr>
+              <a:t>Ce que ça fait au modèle</a:t>
+            </a:r>
+            <a:endParaRPr lang="en-US" sz="1700" dirty="0"/>
+          </a:p>
+        </p:txBody>
+      </p:sp>
+      <p:sp>
+        <p:nvSpPr>
+          <p:cNvPr id="9" name="Text 7"/>
+          <p:cNvSpPr/>
+          <p:nvPr/>
+        </p:nvSpPr>
+        <p:spPr>
+          <a:xfrm>
+            <a:off x="6675120" y="2377440"/>
+            <a:ext cx="4572000" cy="1005840"/>
+          </a:xfrm>
+          <a:prstGeom prst="rect">
+            <a:avLst/>
+          </a:prstGeom>
+          <a:noFill/>
+          <a:ln/>
+        </p:spPr>
+        <p:txBody>
+          <a:bodyPr wrap="square" lIns="0" tIns="0" rIns="0" bIns="0" rtlCol="0" anchor="ctr"/>
+          <a:lstStyle/>
+          <a:p>
+            <a:pPr indent="0" marL="0">
+              <a:lnSpc>
+                <a:spcPct val="115000"/>
+              </a:lnSpc>
+              <a:buNone/>
+            </a:pPr>
+            <a:r>
+              <a:rPr lang="en-US" sz="1200" dirty="0">
+                <a:solidFill>
+                  <a:srgbClr val="FFFFFF"/>
+                </a:solidFill>
+                <a:latin typeface="Calibri" pitchFamily="34" charset="0"/>
+                <a:ea typeface="Calibri" pitchFamily="34" charset="-122"/>
+                <a:cs typeface="Calibri" pitchFamily="34" charset="-120"/>
+              </a:rPr>
+              <a:t>Un modèle déclaré en 18 versions pèse 18 fois plus lourd dans la somme des carrés. L'ajustement suit le catalogue commercial, pas la physique.</a:t>
+            </a:r>
+            <a:endParaRPr lang="en-US" sz="1200" dirty="0"/>
+          </a:p>
+        </p:txBody>
+      </p:sp>
+      <p:sp>
+        <p:nvSpPr>
+          <p:cNvPr id="10" name="Shape 8"/>
+          <p:cNvSpPr/>
+          <p:nvPr/>
+        </p:nvSpPr>
+        <p:spPr>
+          <a:xfrm>
+            <a:off x="640080" y="3794760"/>
+            <a:ext cx="10881360" cy="1051560"/>
+          </a:xfrm>
+          <a:prstGeom prst="roundRect">
+            <a:avLst>
+              <a:gd name="adj" fmla="val 6957"/>
+            </a:avLst>
+          </a:prstGeom>
+          <a:solidFill>
+            <a:srgbClr val="EDF2E6"/>
+          </a:solidFill>
+          <a:ln w="12700">
+            <a:solidFill>
+              <a:srgbClr val="EDF2E6"/>
+            </a:solidFill>
+            <a:prstDash val="solid"/>
+          </a:ln>
+        </p:spPr>
+      </p:sp>
+      <p:sp>
+        <p:nvSpPr>
+          <p:cNvPr id="11" name="Text 9"/>
+          <p:cNvSpPr/>
+          <p:nvPr/>
+        </p:nvSpPr>
+        <p:spPr>
+          <a:xfrm>
+            <a:off x="1005840" y="3931920"/>
+            <a:ext cx="2743200" cy="685800"/>
+          </a:xfrm>
+          <a:prstGeom prst="rect">
+            <a:avLst/>
+          </a:prstGeom>
+          <a:noFill/>
+          <a:ln/>
+        </p:spPr>
+        <p:txBody>
+          <a:bodyPr wrap="square" lIns="0" tIns="0" rIns="0" bIns="0" rtlCol="0" anchor="ctr"/>
+          <a:lstStyle/>
+          <a:p>
+            <a:pPr indent="0" marL="0">
+              <a:buNone/>
+            </a:pPr>
+            <a:r>
+              <a:rPr lang="en-US" sz="3200" b="1" dirty="0">
+                <a:solidFill>
+                  <a:srgbClr val="5E6E5E"/>
+                </a:solidFill>
+                <a:latin typeface="Cambria" pitchFamily="34" charset="0"/>
+                <a:ea typeface="Cambria" pitchFamily="34" charset="-122"/>
+                <a:cs typeface="Cambria" pitchFamily="34" charset="-120"/>
+              </a:rPr>
+              <a:t>6 934</a:t>
+            </a:r>
+            <a:endParaRPr lang="en-US" sz="3200" dirty="0"/>
+          </a:p>
+        </p:txBody>
+      </p:sp>
+      <p:sp>
+        <p:nvSpPr>
+          <p:cNvPr id="12" name="Text 10"/>
+          <p:cNvSpPr/>
+          <p:nvPr/>
+        </p:nvSpPr>
+        <p:spPr>
+          <a:xfrm>
+            <a:off x="1005840" y="4526280"/>
+            <a:ext cx="3108960" cy="274320"/>
+          </a:xfrm>
+          <a:prstGeom prst="rect">
+            <a:avLst/>
+          </a:prstGeom>
+          <a:noFill/>
+          <a:ln/>
+        </p:spPr>
+        <p:txBody>
+          <a:bodyPr wrap="square" lIns="0" tIns="0" rIns="0" bIns="0" rtlCol="0" anchor="ctr"/>
+          <a:lstStyle/>
+          <a:p>
+            <a:pPr indent="0" marL="0">
+              <a:buNone/>
+            </a:pPr>
+            <a:r>
+              <a:rPr lang="en-US" sz="1150" dirty="0">
+                <a:solidFill>
+                  <a:srgbClr val="5E6E5E"/>
+                </a:solidFill>
+                <a:latin typeface="Calibri" pitchFamily="34" charset="0"/>
+                <a:ea typeface="Calibri" pitchFamily="34" charset="-122"/>
+                <a:cs typeface="Calibri" pitchFamily="34" charset="-120"/>
+              </a:rPr>
+              <a:t>lignes essence dans le fichier</a:t>
+            </a:r>
+            <a:endParaRPr lang="en-US" sz="1150" dirty="0"/>
+          </a:p>
+        </p:txBody>
+      </p:sp>
+      <p:sp>
+        <p:nvSpPr>
+          <p:cNvPr id="13" name="Text 11"/>
+          <p:cNvSpPr/>
+          <p:nvPr/>
+        </p:nvSpPr>
+        <p:spPr>
+          <a:xfrm>
+            <a:off x="4480560" y="4023360"/>
+            <a:ext cx="731520" cy="457200"/>
+          </a:xfrm>
+          <a:prstGeom prst="rect">
+            <a:avLst/>
+          </a:prstGeom>
+          <a:noFill/>
+          <a:ln/>
+        </p:spPr>
+        <p:txBody>
+          <a:bodyPr wrap="square" lIns="0" tIns="0" rIns="0" bIns="0" rtlCol="0" anchor="ctr"/>
+          <a:lstStyle/>
+          <a:p>
+            <a:pPr algn="ctr" indent="0" marL="0">
+              <a:buNone/>
+            </a:pPr>
+            <a:r>
+              <a:rPr lang="en-US" sz="2600" b="1" dirty="0">
+                <a:solidFill>
+                  <a:srgbClr val="97BC62"/>
+                </a:solidFill>
+                <a:latin typeface="Calibri" pitchFamily="34" charset="0"/>
+                <a:ea typeface="Calibri" pitchFamily="34" charset="-122"/>
+                <a:cs typeface="Calibri" pitchFamily="34" charset="-120"/>
+              </a:rPr>
+              <a:t>→</a:t>
+            </a:r>
+            <a:endParaRPr lang="en-US" sz="2600" dirty="0"/>
+          </a:p>
+        </p:txBody>
+      </p:sp>
+      <p:sp>
+        <p:nvSpPr>
+          <p:cNvPr id="14" name="Text 12"/>
+          <p:cNvSpPr/>
+          <p:nvPr/>
+        </p:nvSpPr>
+        <p:spPr>
+          <a:xfrm>
+            <a:off x="5669280" y="3931920"/>
+            <a:ext cx="2743200" cy="685800"/>
+          </a:xfrm>
+          <a:prstGeom prst="rect">
+            <a:avLst/>
+          </a:prstGeom>
+          <a:noFill/>
+          <a:ln/>
+        </p:spPr>
+        <p:txBody>
+          <a:bodyPr wrap="square" lIns="0" tIns="0" rIns="0" bIns="0" rtlCol="0" anchor="ctr"/>
+          <a:lstStyle/>
+          <a:p>
+            <a:pPr indent="0" marL="0">
+              <a:buNone/>
+            </a:pPr>
+            <a:r>
+              <a:rPr lang="en-US" sz="3200" b="1" dirty="0">
+                <a:solidFill>
+                  <a:srgbClr val="2C5F2D"/>
+                </a:solidFill>
+                <a:latin typeface="Cambria" pitchFamily="34" charset="0"/>
+                <a:ea typeface="Cambria" pitchFamily="34" charset="-122"/>
+                <a:cs typeface="Cambria" pitchFamily="34" charset="-120"/>
+              </a:rPr>
+              <a:t>2 406</a:t>
+            </a:r>
+            <a:endParaRPr lang="en-US" sz="3200" dirty="0"/>
+          </a:p>
+        </p:txBody>
+      </p:sp>
+      <p:sp>
+        <p:nvSpPr>
+          <p:cNvPr id="15" name="Text 13"/>
+          <p:cNvSpPr/>
+          <p:nvPr/>
+        </p:nvSpPr>
+        <p:spPr>
+          <a:xfrm>
+            <a:off x="5669280" y="4526280"/>
+            <a:ext cx="5029200" cy="274320"/>
+          </a:xfrm>
+          <a:prstGeom prst="rect">
+            <a:avLst/>
+          </a:prstGeom>
+          <a:noFill/>
+          <a:ln/>
+        </p:spPr>
+        <p:txBody>
+          <a:bodyPr wrap="square" lIns="0" tIns="0" rIns="0" bIns="0" rtlCol="0" anchor="ctr"/>
+          <a:lstStyle/>
+          <a:p>
+            <a:pPr indent="0" marL="0">
+              <a:buNone/>
+            </a:pPr>
+            <a:r>
+              <a:rPr lang="en-US" sz="1150" dirty="0">
+                <a:solidFill>
+                  <a:srgbClr val="1F2A1F"/>
+                </a:solidFill>
+                <a:latin typeface="Calibri" pitchFamily="34" charset="0"/>
+                <a:ea typeface="Calibri" pitchFamily="34" charset="-122"/>
+                <a:cs typeface="Calibri" pitchFamily="34" charset="-120"/>
+              </a:rPr>
+              <a:t>véhicules après dédoublonnage</a:t>
+            </a:r>
+            <a:endParaRPr lang="en-US" sz="1150" dirty="0"/>
+          </a:p>
+        </p:txBody>
+      </p:sp>
+      <p:sp>
+        <p:nvSpPr>
+          <p:cNvPr id="16" name="Shape 14"/>
+          <p:cNvSpPr/>
+          <p:nvPr/>
+        </p:nvSpPr>
+        <p:spPr>
+          <a:xfrm>
+            <a:off x="640080" y="5074920"/>
+            <a:ext cx="10881360" cy="777240"/>
+          </a:xfrm>
+          <a:prstGeom prst="roundRect">
+            <a:avLst>
+              <a:gd name="adj" fmla="val 9412"/>
+            </a:avLst>
+          </a:prstGeom>
+          <a:solidFill>
+            <a:srgbClr val="EDF2E6"/>
+          </a:solidFill>
+          <a:ln w="12700">
+            <a:solidFill>
+              <a:srgbClr val="EDF2E6"/>
+            </a:solidFill>
+            <a:prstDash val="solid"/>
+          </a:ln>
+        </p:spPr>
+      </p:sp>
+      <p:sp>
+        <p:nvSpPr>
+          <p:cNvPr id="17" name="Text 15"/>
+          <p:cNvSpPr/>
+          <p:nvPr/>
+        </p:nvSpPr>
+        <p:spPr>
+          <a:xfrm>
+            <a:off x="960120" y="5193792"/>
+            <a:ext cx="10241280" cy="548640"/>
+          </a:xfrm>
+          <a:prstGeom prst="rect">
+            <a:avLst/>
+          </a:prstGeom>
+          <a:noFill/>
+          <a:ln/>
+        </p:spPr>
+        <p:txBody>
+          <a:bodyPr wrap="square" lIns="0" tIns="0" rIns="0" bIns="0" rtlCol="0" anchor="ctr"/>
+          <a:lstStyle/>
+          <a:p>
+            <a:pPr indent="0" marL="0">
+              <a:buNone/>
+            </a:pPr>
+            <a:r>
+              <a:rPr lang="en-US" sz="1300" dirty="0">
+                <a:solidFill>
+                  <a:srgbClr val="1F2A1F"/>
+                </a:solidFill>
+                <a:latin typeface="Calibri" pitchFamily="34" charset="0"/>
+                <a:ea typeface="Calibri" pitchFamily="34" charset="-122"/>
+                <a:cs typeface="Calibri" pitchFamily="34" charset="-120"/>
+              </a:rPr>
+              <a:t>Dédoublonner sur des clés métier explicites — et dire lesquelles. Ici : marque, modèle, masse, puissance, CO₂.</a:t>
+            </a:r>
+            <a:endParaRPr lang="en-US" sz="1300" dirty="0"/>
+          </a:p>
+        </p:txBody>
+      </p:sp>
+    </p:spTree>
+  </p:cSld>
+  <p:clrMapOvr>
+    <a:masterClrMapping/>
+  </p:clrMapOvr>
+</p:sld>
+</file>
+
+<file path=ppt/slides/slide18.xml><?xml version="1.0" encoding="utf-8"?>
+<p:sld xmlns:a="http://schemas.openxmlformats.org/drawingml/2006/main" xmlns:r="http://schemas.openxmlformats.org/officeDocument/2006/relationships" xmlns:p="http://schemas.openxmlformats.org/presentationml/2006/main">
+  <p:cSld name="Slide 12">
+    <p:spTree>
+      <p:nvGrpSpPr>
+        <p:cNvPr id="1" name=""/>
+        <p:cNvGrpSpPr/>
+        <p:nvPr/>
+      </p:nvGrpSpPr>
+      <p:grpSpPr>
+        <a:xfrm>
+          <a:off x="0" y="0"/>
+          <a:ext cx="0" cy="0"/>
+          <a:chOff x="0" y="0"/>
+          <a:chExt cx="0" cy="0"/>
+        </a:xfrm>
+      </p:grpSpPr>
+      <p:sp>
+        <p:nvSpPr>
+          <p:cNvPr id="2" name="Text 0"/>
+          <p:cNvSpPr/>
+          <p:nvPr/>
+        </p:nvSpPr>
+        <p:spPr>
+          <a:xfrm>
+            <a:off x="640080" y="384048"/>
+            <a:ext cx="10881360" cy="685800"/>
+          </a:xfrm>
+          <a:prstGeom prst="rect">
+            <a:avLst/>
+          </a:prstGeom>
+          <a:noFill/>
+          <a:ln/>
+        </p:spPr>
+        <p:txBody>
+          <a:bodyPr wrap="square" lIns="0" tIns="0" rIns="0" bIns="0" rtlCol="0" anchor="ctr"/>
+          <a:lstStyle/>
+          <a:p>
+            <a:pPr indent="0" marL="0">
+              <a:buNone/>
+            </a:pPr>
+            <a:r>
+              <a:rPr lang="en-US" sz="3400" b="1" dirty="0">
+                <a:solidFill>
+                  <a:srgbClr val="1F2A1F"/>
+                </a:solidFill>
+                <a:latin typeface="Cambria" pitchFamily="34" charset="0"/>
+                <a:ea typeface="Cambria" pitchFamily="34" charset="-122"/>
+                <a:cs typeface="Cambria" pitchFamily="34" charset="-120"/>
+              </a:rPr>
+              <a:t>Quand deux variables se recouvrent</a:t>
+            </a:r>
+            <a:endParaRPr lang="en-US" sz="3400" dirty="0"/>
+          </a:p>
+        </p:txBody>
+      </p:sp>
+      <p:sp>
+        <p:nvSpPr>
+          <p:cNvPr id="3" name="Text 1"/>
+          <p:cNvSpPr/>
+          <p:nvPr/>
+        </p:nvSpPr>
+        <p:spPr>
+          <a:xfrm>
+            <a:off x="640080" y="1078992"/>
+            <a:ext cx="10881360" cy="384048"/>
+          </a:xfrm>
+          <a:prstGeom prst="rect">
+            <a:avLst/>
+          </a:prstGeom>
+          <a:noFill/>
+          <a:ln/>
+        </p:spPr>
+        <p:txBody>
+          <a:bodyPr wrap="square" lIns="0" tIns="0" rIns="0" bIns="0" rtlCol="0" anchor="ctr"/>
+          <a:lstStyle/>
+          <a:p>
+            <a:pPr indent="0" marL="0">
+              <a:buNone/>
+            </a:pPr>
+            <a:r>
+              <a:rPr lang="en-US" sz="1400" i="1" dirty="0">
+                <a:solidFill>
+                  <a:srgbClr val="5E6E5E"/>
+                </a:solidFill>
+                <a:latin typeface="Calibri" pitchFamily="34" charset="0"/>
+                <a:ea typeface="Calibri" pitchFamily="34" charset="-122"/>
+                <a:cs typeface="Calibri" pitchFamily="34" charset="-120"/>
+              </a:rPr>
+              <a:t>La colinéarité ne fausse pas les prédictions — elle interdit de lire les coefficients</a:t>
+            </a:r>
+            <a:endParaRPr lang="en-US" sz="1400" dirty="0"/>
+          </a:p>
+        </p:txBody>
+      </p:sp>
+      <p:sp>
+        <p:nvSpPr>
+          <p:cNvPr id="4" name="Shape 2"/>
+          <p:cNvSpPr/>
+          <p:nvPr/>
+        </p:nvSpPr>
+        <p:spPr>
+          <a:xfrm>
+            <a:off x="640080" y="1737360"/>
+            <a:ext cx="3538728" cy="2377440"/>
+          </a:xfrm>
+          <a:prstGeom prst="roundRect">
+            <a:avLst>
+              <a:gd name="adj" fmla="val 3077"/>
+            </a:avLst>
+          </a:prstGeom>
+          <a:solidFill>
+            <a:srgbClr val="EDF2E6"/>
+          </a:solidFill>
+          <a:ln w="12700">
+            <a:solidFill>
+              <a:srgbClr val="EDF2E6"/>
+            </a:solidFill>
+            <a:prstDash val="solid"/>
+          </a:ln>
+        </p:spPr>
+      </p:sp>
+      <p:sp>
+        <p:nvSpPr>
+          <p:cNvPr id="5" name="Text 3"/>
+          <p:cNvSpPr/>
+          <p:nvPr/>
+        </p:nvSpPr>
+        <p:spPr>
+          <a:xfrm>
+            <a:off x="914400" y="1920240"/>
+            <a:ext cx="3017520" cy="502920"/>
+          </a:xfrm>
+          <a:prstGeom prst="rect">
+            <a:avLst/>
+          </a:prstGeom>
+          <a:noFill/>
+          <a:ln/>
+        </p:spPr>
+        <p:txBody>
+          <a:bodyPr wrap="square" lIns="0" tIns="0" rIns="0" bIns="0" rtlCol="0" anchor="ctr"/>
+          <a:lstStyle/>
+          <a:p>
+            <a:pPr indent="0" marL="0">
+              <a:buNone/>
+            </a:pPr>
+            <a:r>
+              <a:rPr lang="en-US" sz="2400" b="1" dirty="0">
+                <a:solidFill>
+                  <a:srgbClr val="2C5F2D"/>
+                </a:solidFill>
+                <a:latin typeface="Cambria" pitchFamily="34" charset="0"/>
+                <a:ea typeface="Cambria" pitchFamily="34" charset="-122"/>
+                <a:cs typeface="Cambria" pitchFamily="34" charset="-120"/>
+              </a:rPr>
+              <a:t>Le symptôme</a:t>
+            </a:r>
+            <a:endParaRPr lang="en-US" sz="2400" dirty="0"/>
+          </a:p>
+        </p:txBody>
+      </p:sp>
+      <p:sp>
+        <p:nvSpPr>
+          <p:cNvPr id="6" name="Text 4"/>
+          <p:cNvSpPr/>
+          <p:nvPr/>
+        </p:nvSpPr>
+        <p:spPr>
+          <a:xfrm>
+            <a:off x="914400" y="2542032"/>
+            <a:ext cx="3017520" cy="1371600"/>
+          </a:xfrm>
+          <a:prstGeom prst="rect">
+            <a:avLst/>
+          </a:prstGeom>
+          <a:noFill/>
+          <a:ln/>
+        </p:spPr>
+        <p:txBody>
+          <a:bodyPr wrap="square" lIns="0" tIns="0" rIns="0" bIns="0" rtlCol="0" anchor="t"/>
+          <a:lstStyle/>
+          <a:p>
+            <a:pPr indent="0" marL="0">
+              <a:lnSpc>
+                <a:spcPct val="115000"/>
+              </a:lnSpc>
+              <a:buNone/>
+            </a:pPr>
+            <a:r>
+              <a:rPr lang="en-US" sz="1200" dirty="0">
+                <a:solidFill>
+                  <a:srgbClr val="1F2A1F"/>
+                </a:solidFill>
+                <a:latin typeface="Calibri" pitchFamily="34" charset="0"/>
+                <a:ea typeface="Calibri" pitchFamily="34" charset="-122"/>
+                <a:cs typeface="Calibri" pitchFamily="34" charset="-120"/>
+              </a:rPr>
+              <a:t>Un coefficient au signe physiquement absurde : à masse égale, plus le véhicule serait puissant, moins il émettrait.</a:t>
+            </a:r>
+            <a:endParaRPr lang="en-US" sz="1200" dirty="0"/>
+          </a:p>
+        </p:txBody>
+      </p:sp>
+      <p:sp>
+        <p:nvSpPr>
+          <p:cNvPr id="7" name="Shape 5"/>
+          <p:cNvSpPr/>
+          <p:nvPr/>
+        </p:nvSpPr>
+        <p:spPr>
+          <a:xfrm>
+            <a:off x="4361688" y="1737360"/>
+            <a:ext cx="3538728" cy="2377440"/>
+          </a:xfrm>
+          <a:prstGeom prst="roundRect">
+            <a:avLst>
+              <a:gd name="adj" fmla="val 3077"/>
+            </a:avLst>
+          </a:prstGeom>
+          <a:solidFill>
+            <a:srgbClr val="EDF2E6"/>
+          </a:solidFill>
+          <a:ln w="12700">
+            <a:solidFill>
+              <a:srgbClr val="EDF2E6"/>
+            </a:solidFill>
+            <a:prstDash val="solid"/>
+          </a:ln>
+        </p:spPr>
+      </p:sp>
+      <p:sp>
+        <p:nvSpPr>
+          <p:cNvPr id="8" name="Text 6"/>
+          <p:cNvSpPr/>
+          <p:nvPr/>
+        </p:nvSpPr>
+        <p:spPr>
+          <a:xfrm>
+            <a:off x="4636008" y="1920240"/>
+            <a:ext cx="3017520" cy="502920"/>
+          </a:xfrm>
+          <a:prstGeom prst="rect">
+            <a:avLst/>
+          </a:prstGeom>
+          <a:noFill/>
+          <a:ln/>
+        </p:spPr>
+        <p:txBody>
+          <a:bodyPr wrap="square" lIns="0" tIns="0" rIns="0" bIns="0" rtlCol="0" anchor="ctr"/>
+          <a:lstStyle/>
+          <a:p>
+            <a:pPr indent="0" marL="0">
+              <a:buNone/>
+            </a:pPr>
+            <a:r>
+              <a:rPr lang="en-US" sz="2400" b="1" dirty="0">
+                <a:solidFill>
+                  <a:srgbClr val="2C5F2D"/>
+                </a:solidFill>
+                <a:latin typeface="Cambria" pitchFamily="34" charset="0"/>
+                <a:ea typeface="Cambria" pitchFamily="34" charset="-122"/>
+                <a:cs typeface="Cambria" pitchFamily="34" charset="-120"/>
+              </a:rPr>
+              <a:t>Le diagnostic</a:t>
+            </a:r>
+            <a:endParaRPr lang="en-US" sz="2400" dirty="0"/>
+          </a:p>
+        </p:txBody>
+      </p:sp>
+      <p:sp>
+        <p:nvSpPr>
+          <p:cNvPr id="9" name="Text 7"/>
+          <p:cNvSpPr/>
+          <p:nvPr/>
+        </p:nvSpPr>
+        <p:spPr>
+          <a:xfrm>
+            <a:off x="4636008" y="2542032"/>
+            <a:ext cx="3017520" cy="1371600"/>
+          </a:xfrm>
+          <a:prstGeom prst="rect">
+            <a:avLst/>
+          </a:prstGeom>
+          <a:noFill/>
+          <a:ln/>
+        </p:spPr>
+        <p:txBody>
+          <a:bodyPr wrap="square" lIns="0" tIns="0" rIns="0" bIns="0" rtlCol="0" anchor="t"/>
+          <a:lstStyle/>
+          <a:p>
+            <a:pPr indent="0" marL="0">
+              <a:lnSpc>
+                <a:spcPct val="115000"/>
+              </a:lnSpc>
+              <a:buNone/>
+            </a:pPr>
+            <a:r>
+              <a:rPr lang="en-US" sz="1200" dirty="0">
+                <a:solidFill>
+                  <a:srgbClr val="1F2A1F"/>
+                </a:solidFill>
+                <a:latin typeface="Calibri" pitchFamily="34" charset="0"/>
+                <a:ea typeface="Calibri" pitchFamily="34" charset="-122"/>
+                <a:cs typeface="Calibri" pitchFamily="34" charset="-120"/>
+              </a:rPr>
+              <a:t>Dans l'ordre : corrélation entre variables, R² de chacune seule, puis gain incrémental. Un gain nul = le coefficient ajuste du bruit.</a:t>
+            </a:r>
+            <a:endParaRPr lang="en-US" sz="1200" dirty="0"/>
+          </a:p>
+        </p:txBody>
+      </p:sp>
+      <p:sp>
+        <p:nvSpPr>
+          <p:cNvPr id="10" name="Shape 8"/>
+          <p:cNvSpPr/>
+          <p:nvPr/>
+        </p:nvSpPr>
+        <p:spPr>
+          <a:xfrm>
+            <a:off x="8083296" y="1737360"/>
+            <a:ext cx="3538728" cy="2377440"/>
+          </a:xfrm>
+          <a:prstGeom prst="roundRect">
+            <a:avLst>
+              <a:gd name="adj" fmla="val 3077"/>
+            </a:avLst>
+          </a:prstGeom>
+          <a:solidFill>
+            <a:srgbClr val="EDF2E6"/>
+          </a:solidFill>
+          <a:ln w="12700">
+            <a:solidFill>
+              <a:srgbClr val="EDF2E6"/>
+            </a:solidFill>
+            <a:prstDash val="solid"/>
+          </a:ln>
+        </p:spPr>
+      </p:sp>
+      <p:sp>
+        <p:nvSpPr>
+          <p:cNvPr id="11" name="Text 9"/>
+          <p:cNvSpPr/>
+          <p:nvPr/>
+        </p:nvSpPr>
+        <p:spPr>
+          <a:xfrm>
+            <a:off x="8357616" y="1920240"/>
+            <a:ext cx="3017520" cy="502920"/>
+          </a:xfrm>
+          <a:prstGeom prst="rect">
+            <a:avLst/>
+          </a:prstGeom>
+          <a:noFill/>
+          <a:ln/>
+        </p:spPr>
+        <p:txBody>
+          <a:bodyPr wrap="square" lIns="0" tIns="0" rIns="0" bIns="0" rtlCol="0" anchor="ctr"/>
+          <a:lstStyle/>
+          <a:p>
+            <a:pPr indent="0" marL="0">
+              <a:buNone/>
+            </a:pPr>
+            <a:r>
+              <a:rPr lang="en-US" sz="2400" b="1" dirty="0">
+                <a:solidFill>
+                  <a:srgbClr val="C0562F"/>
+                </a:solidFill>
+                <a:latin typeface="Cambria" pitchFamily="34" charset="0"/>
+                <a:ea typeface="Cambria" pitchFamily="34" charset="-122"/>
+                <a:cs typeface="Cambria" pitchFamily="34" charset="-120"/>
+              </a:rPr>
+              <a:t>La conséquence</a:t>
+            </a:r>
+            <a:endParaRPr lang="en-US" sz="2400" dirty="0"/>
+          </a:p>
+        </p:txBody>
+      </p:sp>
+      <p:sp>
+        <p:nvSpPr>
+          <p:cNvPr id="12" name="Text 10"/>
+          <p:cNvSpPr/>
+          <p:nvPr/>
+        </p:nvSpPr>
+        <p:spPr>
+          <a:xfrm>
+            <a:off x="8357616" y="2542032"/>
+            <a:ext cx="3017520" cy="1371600"/>
+          </a:xfrm>
+          <a:prstGeom prst="rect">
+            <a:avLst/>
+          </a:prstGeom>
+          <a:noFill/>
+          <a:ln/>
+        </p:spPr>
+        <p:txBody>
+          <a:bodyPr wrap="square" lIns="0" tIns="0" rIns="0" bIns="0" rtlCol="0" anchor="t"/>
+          <a:lstStyle/>
+          <a:p>
+            <a:pPr indent="0" marL="0">
+              <a:lnSpc>
+                <a:spcPct val="115000"/>
+              </a:lnSpc>
+              <a:buNone/>
+            </a:pPr>
+            <a:r>
+              <a:rPr lang="en-US" sz="1200" dirty="0">
+                <a:solidFill>
+                  <a:srgbClr val="1F2A1F"/>
+                </a:solidFill>
+                <a:latin typeface="Calibri" pitchFamily="34" charset="0"/>
+                <a:ea typeface="Calibri" pitchFamily="34" charset="-122"/>
+                <a:cs typeface="Calibri" pitchFamily="34" charset="-120"/>
+              </a:rPr>
+              <a:t>Les coefficients ne s'interprètent plus un par un. Seule leur combinaison prédit — et le modèle reste utilisable.</a:t>
+            </a:r>
+            <a:endParaRPr lang="en-US" sz="1200" dirty="0"/>
+          </a:p>
+        </p:txBody>
+      </p:sp>
+      <p:sp>
+        <p:nvSpPr>
+          <p:cNvPr id="13" name="Shape 11"/>
+          <p:cNvSpPr/>
+          <p:nvPr/>
+        </p:nvSpPr>
+        <p:spPr>
+          <a:xfrm>
+            <a:off x="640080" y="4389120"/>
+            <a:ext cx="10881360" cy="1371600"/>
+          </a:xfrm>
+          <a:prstGeom prst="roundRect">
+            <a:avLst>
+              <a:gd name="adj" fmla="val 5333"/>
+            </a:avLst>
+          </a:prstGeom>
+          <a:solidFill>
+            <a:srgbClr val="1A3A1C"/>
+          </a:solidFill>
+          <a:ln w="12700">
+            <a:solidFill>
+              <a:srgbClr val="1A3A1C"/>
+            </a:solidFill>
+            <a:prstDash val="solid"/>
+          </a:ln>
+        </p:spPr>
+      </p:sp>
+      <p:sp>
+        <p:nvSpPr>
+          <p:cNvPr id="14" name="Text 12"/>
+          <p:cNvSpPr/>
+          <p:nvPr/>
+        </p:nvSpPr>
+        <p:spPr>
+          <a:xfrm>
+            <a:off x="960120" y="4553712"/>
+            <a:ext cx="10241280" cy="320040"/>
+          </a:xfrm>
+          <a:prstGeom prst="rect">
+            <a:avLst/>
+          </a:prstGeom>
+          <a:noFill/>
+          <a:ln/>
+        </p:spPr>
+        <p:txBody>
+          <a:bodyPr wrap="square" lIns="0" tIns="0" rIns="0" bIns="0" rtlCol="0" anchor="ctr"/>
+          <a:lstStyle/>
+          <a:p>
+            <a:pPr indent="0" marL="0">
+              <a:buNone/>
+            </a:pPr>
+            <a:r>
+              <a:rPr lang="en-US" sz="1500" b="1" dirty="0">
+                <a:solidFill>
+                  <a:srgbClr val="97BC62"/>
+                </a:solidFill>
+                <a:latin typeface="Cambria" pitchFamily="34" charset="0"/>
+                <a:ea typeface="Cambria" pitchFamily="34" charset="-122"/>
+                <a:cs typeface="Cambria" pitchFamily="34" charset="-120"/>
+              </a:rPr>
+              <a:t>Les R² ne s'additionnent pas</a:t>
+            </a:r>
+            <a:endParaRPr lang="en-US" sz="1500" dirty="0"/>
+          </a:p>
+        </p:txBody>
+      </p:sp>
+      <p:sp>
+        <p:nvSpPr>
+          <p:cNvPr id="15" name="Text 13"/>
+          <p:cNvSpPr/>
+          <p:nvPr/>
+        </p:nvSpPr>
+        <p:spPr>
+          <a:xfrm>
+            <a:off x="960120" y="4937760"/>
+            <a:ext cx="10241280" cy="685800"/>
+          </a:xfrm>
+          <a:prstGeom prst="rect">
+            <a:avLst/>
+          </a:prstGeom>
+          <a:noFill/>
+          <a:ln/>
+        </p:spPr>
+        <p:txBody>
+          <a:bodyPr wrap="square" lIns="0" tIns="0" rIns="0" bIns="0" rtlCol="0" anchor="ctr"/>
+          <a:lstStyle/>
+          <a:p>
+            <a:pPr indent="0" marL="0">
+              <a:lnSpc>
+                <a:spcPct val="115000"/>
+              </a:lnSpc>
+              <a:buNone/>
+            </a:pPr>
+            <a:r>
+              <a:rPr lang="en-US" sz="1250" dirty="0">
+                <a:solidFill>
+                  <a:srgbClr val="FFFFFF"/>
+                </a:solidFill>
+                <a:latin typeface="Calibri" pitchFamily="34" charset="0"/>
+                <a:ea typeface="Calibri" pitchFamily="34" charset="-122"/>
+                <a:cs typeface="Calibri" pitchFamily="34" charset="-120"/>
+              </a:rPr>
+              <a:t>0,6158 pour la masse seule, 0,7618 pour la puissance seule, 0,7886 pour les deux ensemble. L'information commune est partagée, pas additive : c'est le gain incrémental qui compte, jamais le R² d'une variable prise seule.</a:t>
+            </a:r>
+            <a:endParaRPr lang="en-US" sz="1250" dirty="0"/>
+          </a:p>
+        </p:txBody>
+      </p:sp>
+    </p:spTree>
+  </p:cSld>
+  <p:clrMapOvr>
+    <a:masterClrMapping/>
+  </p:clrMapOvr>
+</p:sld>
+</file>
+
+<file path=ppt/slides/slide19.xml><?xml version="1.0" encoding="utf-8"?>
+<p:sld xmlns:a="http://schemas.openxmlformats.org/drawingml/2006/main" xmlns:r="http://schemas.openxmlformats.org/officeDocument/2006/relationships" xmlns:p="http://schemas.openxmlformats.org/presentationml/2006/main">
+  <p:cSld name="Slide 12">
+    <p:spTree>
+      <p:nvGrpSpPr>
+        <p:cNvPr id="1" name=""/>
+        <p:cNvGrpSpPr/>
+        <p:nvPr/>
+      </p:nvGrpSpPr>
+      <p:grpSpPr>
+        <a:xfrm>
+          <a:off x="0" y="0"/>
+          <a:ext cx="0" cy="0"/>
+          <a:chOff x="0" y="0"/>
+          <a:chExt cx="0" cy="0"/>
+        </a:xfrm>
+      </p:grpSpPr>
+      <p:sp>
+        <p:nvSpPr>
+          <p:cNvPr id="2" name="Text 0"/>
+          <p:cNvSpPr/>
+          <p:nvPr/>
+        </p:nvSpPr>
+        <p:spPr>
+          <a:xfrm>
+            <a:off x="640080" y="384048"/>
+            <a:ext cx="10881360" cy="685800"/>
+          </a:xfrm>
+          <a:prstGeom prst="rect">
+            <a:avLst/>
+          </a:prstGeom>
+          <a:noFill/>
+          <a:ln/>
+        </p:spPr>
+        <p:txBody>
+          <a:bodyPr wrap="square" lIns="0" tIns="0" rIns="0" bIns="0" rtlCol="0" anchor="ctr"/>
+          <a:lstStyle/>
+          <a:p>
+            <a:pPr indent="0" marL="0">
+              <a:buNone/>
+            </a:pPr>
+            <a:r>
+              <a:rPr lang="en-US" sz="3400" b="1" dirty="0">
+                <a:solidFill>
+                  <a:srgbClr val="1F2A1F"/>
+                </a:solidFill>
+                <a:latin typeface="Cambria" pitchFamily="34" charset="0"/>
+                <a:ea typeface="Cambria" pitchFamily="34" charset="-122"/>
+                <a:cs typeface="Cambria" pitchFamily="34" charset="-120"/>
+              </a:rPr>
+              <a:t>Le R² d'entraînement ne peut que monter</a:t>
+            </a:r>
+            <a:endParaRPr lang="en-US" sz="3400" dirty="0"/>
+          </a:p>
+        </p:txBody>
+      </p:sp>
+      <p:sp>
+        <p:nvSpPr>
+          <p:cNvPr id="3" name="Text 1"/>
+          <p:cNvSpPr/>
+          <p:nvPr/>
+        </p:nvSpPr>
+        <p:spPr>
+          <a:xfrm>
+            <a:off x="640080" y="1078992"/>
+            <a:ext cx="10881360" cy="384048"/>
+          </a:xfrm>
+          <a:prstGeom prst="rect">
+            <a:avLst/>
+          </a:prstGeom>
+          <a:noFill/>
+          <a:ln/>
+        </p:spPr>
+        <p:txBody>
+          <a:bodyPr wrap="square" lIns="0" tIns="0" rIns="0" bIns="0" rtlCol="0" anchor="ctr"/>
+          <a:lstStyle/>
+          <a:p>
+            <a:pPr indent="0" marL="0">
+              <a:buNone/>
+            </a:pPr>
+            <a:r>
+              <a:rPr lang="en-US" sz="1400" i="1" dirty="0">
+                <a:solidFill>
+                  <a:srgbClr val="5E6E5E"/>
+                </a:solidFill>
+                <a:latin typeface="Calibri" pitchFamily="34" charset="0"/>
+                <a:ea typeface="Calibri" pitchFamily="34" charset="-122"/>
+                <a:cs typeface="Calibri" pitchFamily="34" charset="-120"/>
+              </a:rPr>
+              <a:t>Dès que le nombre de paramètres varie, il cesse d'être un critère de comparaison</a:t>
+            </a:r>
+            <a:endParaRPr lang="en-US" sz="1400" dirty="0"/>
+          </a:p>
+        </p:txBody>
+      </p:sp>
+      <p:sp>
+        <p:nvSpPr>
+          <p:cNvPr id="4" name="Shape 2"/>
+          <p:cNvSpPr/>
+          <p:nvPr/>
+        </p:nvSpPr>
+        <p:spPr>
+          <a:xfrm>
+            <a:off x="640080" y="1737360"/>
+            <a:ext cx="3538728" cy="2377440"/>
+          </a:xfrm>
+          <a:prstGeom prst="roundRect">
+            <a:avLst>
+              <a:gd name="adj" fmla="val 3077"/>
+            </a:avLst>
+          </a:prstGeom>
+          <a:solidFill>
+            <a:srgbClr val="EDF2E6"/>
+          </a:solidFill>
+          <a:ln w="12700">
+            <a:solidFill>
+              <a:srgbClr val="EDF2E6"/>
+            </a:solidFill>
+            <a:prstDash val="solid"/>
+          </a:ln>
+        </p:spPr>
+      </p:sp>
+      <p:sp>
+        <p:nvSpPr>
+          <p:cNvPr id="5" name="Text 3"/>
+          <p:cNvSpPr/>
+          <p:nvPr/>
+        </p:nvSpPr>
+        <p:spPr>
+          <a:xfrm>
+            <a:off x="914400" y="1920240"/>
+            <a:ext cx="3017520" cy="502920"/>
+          </a:xfrm>
+          <a:prstGeom prst="rect">
+            <a:avLst/>
+          </a:prstGeom>
+          <a:noFill/>
+          <a:ln/>
+        </p:spPr>
+        <p:txBody>
+          <a:bodyPr wrap="square" lIns="0" tIns="0" rIns="0" bIns="0" rtlCol="0" anchor="ctr"/>
+          <a:lstStyle/>
+          <a:p>
+            <a:pPr indent="0" marL="0">
+              <a:buNone/>
+            </a:pPr>
+            <a:r>
+              <a:rPr lang="en-US" sz="2400" b="1" dirty="0">
+                <a:solidFill>
+                  <a:srgbClr val="2C5F2D"/>
+                </a:solidFill>
+                <a:latin typeface="Cambria" pitchFamily="34" charset="0"/>
+                <a:ea typeface="Cambria" pitchFamily="34" charset="-122"/>
+                <a:cs typeface="Cambria" pitchFamily="34" charset="-120"/>
+              </a:rPr>
+              <a:t>Le mécanisme</a:t>
+            </a:r>
+            <a:endParaRPr lang="en-US" sz="2400" dirty="0"/>
+          </a:p>
+        </p:txBody>
+      </p:sp>
+      <p:sp>
+        <p:nvSpPr>
+          <p:cNvPr id="6" name="Text 4"/>
+          <p:cNvSpPr/>
+          <p:nvPr/>
+        </p:nvSpPr>
+        <p:spPr>
+          <a:xfrm>
+            <a:off x="914400" y="2542032"/>
+            <a:ext cx="3017520" cy="1371600"/>
+          </a:xfrm>
+          <a:prstGeom prst="rect">
+            <a:avLst/>
+          </a:prstGeom>
+          <a:noFill/>
+          <a:ln/>
+        </p:spPr>
+        <p:txBody>
+          <a:bodyPr wrap="square" lIns="0" tIns="0" rIns="0" bIns="0" rtlCol="0" anchor="t"/>
+          <a:lstStyle/>
+          <a:p>
+            <a:pPr indent="0" marL="0">
+              <a:lnSpc>
+                <a:spcPct val="115000"/>
+              </a:lnSpc>
+              <a:buNone/>
+            </a:pPr>
+            <a:r>
+              <a:rPr lang="en-US" sz="1200" dirty="0">
+                <a:solidFill>
+                  <a:srgbClr val="1F2A1F"/>
+                </a:solidFill>
+                <a:latin typeface="Calibri" pitchFamily="34" charset="0"/>
+                <a:ea typeface="Calibri" pitchFamily="34" charset="-122"/>
+                <a:cs typeface="Calibri" pitchFamily="34" charset="-120"/>
+              </a:rPr>
+              <a:t>Une variable de plus donne un degré de liberté de plus. Même du bruit pur fait monter le R² d'entraînement.</a:t>
+            </a:r>
+            <a:endParaRPr lang="en-US" sz="1200" dirty="0"/>
+          </a:p>
+        </p:txBody>
+      </p:sp>
+      <p:sp>
+        <p:nvSpPr>
+          <p:cNvPr id="7" name="Shape 5"/>
+          <p:cNvSpPr/>
+          <p:nvPr/>
+        </p:nvSpPr>
+        <p:spPr>
+          <a:xfrm>
+            <a:off x="4361688" y="1737360"/>
+            <a:ext cx="3538728" cy="2377440"/>
+          </a:xfrm>
+          <a:prstGeom prst="roundRect">
+            <a:avLst>
+              <a:gd name="adj" fmla="val 3077"/>
+            </a:avLst>
+          </a:prstGeom>
+          <a:solidFill>
+            <a:srgbClr val="EDF2E6"/>
+          </a:solidFill>
+          <a:ln w="12700">
+            <a:solidFill>
+              <a:srgbClr val="EDF2E6"/>
+            </a:solidFill>
+            <a:prstDash val="solid"/>
+          </a:ln>
+        </p:spPr>
+      </p:sp>
+      <p:sp>
+        <p:nvSpPr>
+          <p:cNvPr id="8" name="Text 6"/>
+          <p:cNvSpPr/>
+          <p:nvPr/>
+        </p:nvSpPr>
+        <p:spPr>
+          <a:xfrm>
+            <a:off x="4636008" y="1920240"/>
+            <a:ext cx="3017520" cy="502920"/>
+          </a:xfrm>
+          <a:prstGeom prst="rect">
+            <a:avLst/>
+          </a:prstGeom>
+          <a:noFill/>
+          <a:ln/>
+        </p:spPr>
+        <p:txBody>
+          <a:bodyPr wrap="square" lIns="0" tIns="0" rIns="0" bIns="0" rtlCol="0" anchor="ctr"/>
+          <a:lstStyle/>
+          <a:p>
+            <a:pPr indent="0" marL="0">
+              <a:buNone/>
+            </a:pPr>
+            <a:r>
+              <a:rPr lang="en-US" sz="2400" b="1" dirty="0">
+                <a:solidFill>
+                  <a:srgbClr val="2C5F2D"/>
+                </a:solidFill>
+                <a:latin typeface="Cambria" pitchFamily="34" charset="0"/>
+                <a:ea typeface="Cambria" pitchFamily="34" charset="-122"/>
+                <a:cs typeface="Cambria" pitchFamily="34" charset="-120"/>
+              </a:rPr>
+              <a:t>Ce que ça masque</a:t>
+            </a:r>
+            <a:endParaRPr lang="en-US" sz="2400" dirty="0"/>
+          </a:p>
+        </p:txBody>
+      </p:sp>
+      <p:sp>
+        <p:nvSpPr>
+          <p:cNvPr id="9" name="Text 7"/>
+          <p:cNvSpPr/>
+          <p:nvPr/>
+        </p:nvSpPr>
+        <p:spPr>
+          <a:xfrm>
+            <a:off x="4636008" y="2542032"/>
+            <a:ext cx="3017520" cy="1371600"/>
+          </a:xfrm>
+          <a:prstGeom prst="rect">
+            <a:avLst/>
+          </a:prstGeom>
+          <a:noFill/>
+          <a:ln/>
+        </p:spPr>
+        <p:txBody>
+          <a:bodyPr wrap="square" lIns="0" tIns="0" rIns="0" bIns="0" rtlCol="0" anchor="t"/>
+          <a:lstStyle/>
+          <a:p>
+            <a:pPr indent="0" marL="0">
+              <a:lnSpc>
+                <a:spcPct val="115000"/>
+              </a:lnSpc>
+              <a:buNone/>
+            </a:pPr>
+            <a:r>
+              <a:rPr lang="en-US" sz="1200" dirty="0">
+                <a:solidFill>
+                  <a:srgbClr val="1F2A1F"/>
+                </a:solidFill>
+                <a:latin typeface="Calibri" pitchFamily="34" charset="0"/>
+                <a:ea typeface="Calibri" pitchFamily="34" charset="-122"/>
+                <a:cs typeface="Calibri" pitchFamily="34" charset="-120"/>
+              </a:rPr>
+              <a:t>Rien ne distingue alors l'information réelle de l'ajustement au bruit. Le ratio inutile et la variable décisive montent tous les deux.</a:t>
+            </a:r>
+            <a:endParaRPr lang="en-US" sz="1200" dirty="0"/>
+          </a:p>
+        </p:txBody>
+      </p:sp>
+      <p:sp>
+        <p:nvSpPr>
+          <p:cNvPr id="10" name="Shape 8"/>
+          <p:cNvSpPr/>
+          <p:nvPr/>
+        </p:nvSpPr>
+        <p:spPr>
+          <a:xfrm>
+            <a:off x="8083296" y="1737360"/>
+            <a:ext cx="3538728" cy="2377440"/>
+          </a:xfrm>
+          <a:prstGeom prst="roundRect">
+            <a:avLst>
+              <a:gd name="adj" fmla="val 3077"/>
+            </a:avLst>
+          </a:prstGeom>
+          <a:solidFill>
+            <a:srgbClr val="EDF2E6"/>
+          </a:solidFill>
+          <a:ln w="12700">
+            <a:solidFill>
+              <a:srgbClr val="EDF2E6"/>
+            </a:solidFill>
+            <a:prstDash val="solid"/>
+          </a:ln>
+        </p:spPr>
+      </p:sp>
+      <p:sp>
+        <p:nvSpPr>
+          <p:cNvPr id="11" name="Text 9"/>
+          <p:cNvSpPr/>
+          <p:nvPr/>
+        </p:nvSpPr>
+        <p:spPr>
+          <a:xfrm>
+            <a:off x="8357616" y="1920240"/>
+            <a:ext cx="3017520" cy="502920"/>
+          </a:xfrm>
+          <a:prstGeom prst="rect">
+            <a:avLst/>
+          </a:prstGeom>
+          <a:noFill/>
+          <a:ln/>
+        </p:spPr>
+        <p:txBody>
+          <a:bodyPr wrap="square" lIns="0" tIns="0" rIns="0" bIns="0" rtlCol="0" anchor="ctr"/>
+          <a:lstStyle/>
+          <a:p>
+            <a:pPr indent="0" marL="0">
+              <a:buNone/>
+            </a:pPr>
+            <a:r>
+              <a:rPr lang="en-US" sz="2400" b="1" dirty="0">
+                <a:solidFill>
+                  <a:srgbClr val="C0562F"/>
+                </a:solidFill>
+                <a:latin typeface="Cambria" pitchFamily="34" charset="0"/>
+                <a:ea typeface="Cambria" pitchFamily="34" charset="-122"/>
+                <a:cs typeface="Cambria" pitchFamily="34" charset="-120"/>
+              </a:rPr>
+              <a:t>Ce qui le remplace</a:t>
+            </a:r>
+            <a:endParaRPr lang="en-US" sz="2400" dirty="0"/>
+          </a:p>
+        </p:txBody>
+      </p:sp>
+      <p:sp>
+        <p:nvSpPr>
+          <p:cNvPr id="12" name="Text 10"/>
+          <p:cNvSpPr/>
+          <p:nvPr/>
+        </p:nvSpPr>
+        <p:spPr>
+          <a:xfrm>
+            <a:off x="8357616" y="2542032"/>
+            <a:ext cx="3017520" cy="1371600"/>
+          </a:xfrm>
+          <a:prstGeom prst="rect">
+            <a:avLst/>
+          </a:prstGeom>
+          <a:noFill/>
+          <a:ln/>
+        </p:spPr>
+        <p:txBody>
+          <a:bodyPr wrap="square" lIns="0" tIns="0" rIns="0" bIns="0" rtlCol="0" anchor="t"/>
+          <a:lstStyle/>
+          <a:p>
+            <a:pPr indent="0" marL="0">
+              <a:lnSpc>
+                <a:spcPct val="115000"/>
+              </a:lnSpc>
+              <a:buNone/>
+            </a:pPr>
+            <a:r>
+              <a:rPr lang="en-US" sz="1200" dirty="0">
+                <a:solidFill>
+                  <a:srgbClr val="1F2A1F"/>
+                </a:solidFill>
+                <a:latin typeface="Calibri" pitchFamily="34" charset="0"/>
+                <a:ea typeface="Calibri" pitchFamily="34" charset="-122"/>
+                <a:cs typeface="Calibri" pitchFamily="34" charset="-120"/>
+              </a:rPr>
+              <a:t>Évaluer sur des données non vues : train_test_split puis R² de test. Ou un R² ajusté, qui pénalise le nombre de paramètres.</a:t>
+            </a:r>
+            <a:endParaRPr lang="en-US" sz="1200" dirty="0"/>
+          </a:p>
+        </p:txBody>
+      </p:sp>
+      <p:sp>
+        <p:nvSpPr>
+          <p:cNvPr id="13" name="Shape 11"/>
+          <p:cNvSpPr/>
+          <p:nvPr/>
+        </p:nvSpPr>
+        <p:spPr>
+          <a:xfrm>
+            <a:off x="640080" y="4389120"/>
+            <a:ext cx="10881360" cy="1371600"/>
+          </a:xfrm>
+          <a:prstGeom prst="roundRect">
+            <a:avLst>
+              <a:gd name="adj" fmla="val 5333"/>
+            </a:avLst>
+          </a:prstGeom>
+          <a:solidFill>
+            <a:srgbClr val="1A3A1C"/>
+          </a:solidFill>
+          <a:ln w="12700">
+            <a:solidFill>
+              <a:srgbClr val="1A3A1C"/>
+            </a:solidFill>
+            <a:prstDash val="solid"/>
+          </a:ln>
+        </p:spPr>
+      </p:sp>
+      <p:sp>
+        <p:nvSpPr>
+          <p:cNvPr id="14" name="Text 12"/>
+          <p:cNvSpPr/>
+          <p:nvPr/>
+        </p:nvSpPr>
+        <p:spPr>
+          <a:xfrm>
+            <a:off x="960120" y="4553712"/>
+            <a:ext cx="10241280" cy="320040"/>
+          </a:xfrm>
+          <a:prstGeom prst="rect">
+            <a:avLst/>
+          </a:prstGeom>
+          <a:noFill/>
+          <a:ln/>
+        </p:spPr>
+        <p:txBody>
+          <a:bodyPr wrap="square" lIns="0" tIns="0" rIns="0" bIns="0" rtlCol="0" anchor="ctr"/>
+          <a:lstStyle/>
+          <a:p>
+            <a:pPr indent="0" marL="0">
+              <a:buNone/>
+            </a:pPr>
+            <a:r>
+              <a:rPr lang="en-US" sz="1500" b="1" dirty="0">
+                <a:solidFill>
+                  <a:srgbClr val="97BC62"/>
+                </a:solidFill>
+                <a:latin typeface="Cambria" pitchFamily="34" charset="0"/>
+                <a:ea typeface="Cambria" pitchFamily="34" charset="-122"/>
+                <a:cs typeface="Cambria" pitchFamily="34" charset="-120"/>
+              </a:rPr>
+              <a:t>Un R² de test supérieur au R² d'entraînement n'est pas une bonne nouvelle</a:t>
+            </a:r>
+            <a:endParaRPr lang="en-US" sz="1500" dirty="0"/>
+          </a:p>
+        </p:txBody>
+      </p:sp>
+      <p:sp>
+        <p:nvSpPr>
+          <p:cNvPr id="15" name="Text 13"/>
+          <p:cNvSpPr/>
+          <p:nvPr/>
+        </p:nvSpPr>
+        <p:spPr>
+          <a:xfrm>
+            <a:off x="960120" y="4937760"/>
+            <a:ext cx="10241280" cy="685800"/>
+          </a:xfrm>
+          <a:prstGeom prst="rect">
+            <a:avLst/>
+          </a:prstGeom>
+          <a:noFill/>
+          <a:ln/>
+        </p:spPr>
+        <p:txBody>
+          <a:bodyPr wrap="square" lIns="0" tIns="0" rIns="0" bIns="0" rtlCol="0" anchor="ctr"/>
+          <a:lstStyle/>
+          <a:p>
+            <a:pPr indent="0" marL="0">
+              <a:lnSpc>
+                <a:spcPct val="115000"/>
+              </a:lnSpc>
+              <a:buNone/>
+            </a:pPr>
+            <a:r>
+              <a:rPr lang="en-US" sz="1250" dirty="0">
+                <a:solidFill>
+                  <a:srgbClr val="FFFFFF"/>
+                </a:solidFill>
+                <a:latin typeface="Calibri" pitchFamily="34" charset="0"/>
+                <a:ea typeface="Calibri" pitchFamily="34" charset="-122"/>
+                <a:cs typeface="Calibri" pitchFamily="34" charset="-120"/>
+              </a:rPr>
+              <a:t>Il signale un tirage favorable, pas un bon modèle. Le classement de plusieurs modèles reste valide s'ils partagent le même découpage ; les valeurs absolues, non. La validation croisée tranche.</a:t>
             </a:r>
             <a:endParaRPr lang="en-US" sz="1250" dirty="0"/>
           </a:p>
@@ -6671,6 +8895,1404 @@
                 <a:cs typeface="Calibri" pitchFamily="34" charset="-120"/>
               </a:rPr>
               <a:t>Le choix de la métrique décide de la conclusion. Toujours savoir ce qu'on mesure.</a:t>
+            </a:r>
+            <a:endParaRPr lang="en-US" sz="1300" dirty="0"/>
+          </a:p>
+        </p:txBody>
+      </p:sp>
+    </p:spTree>
+  </p:cSld>
+  <p:clrMapOvr>
+    <a:masterClrMapping/>
+  </p:clrMapOvr>
+</p:sld>
+</file>
+
+<file path=ppt/slides/slide20.xml><?xml version="1.0" encoding="utf-8"?>
+<p:sld xmlns:a="http://schemas.openxmlformats.org/drawingml/2006/main" xmlns:r="http://schemas.openxmlformats.org/officeDocument/2006/relationships" xmlns:p="http://schemas.openxmlformats.org/presentationml/2006/main">
+  <p:cSld name="Slide 11">
+    <p:spTree>
+      <p:nvGrpSpPr>
+        <p:cNvPr id="1" name=""/>
+        <p:cNvGrpSpPr/>
+        <p:nvPr/>
+      </p:nvGrpSpPr>
+      <p:grpSpPr>
+        <a:xfrm>
+          <a:off x="0" y="0"/>
+          <a:ext cx="0" cy="0"/>
+          <a:chOff x="0" y="0"/>
+          <a:chExt cx="0" cy="0"/>
+        </a:xfrm>
+      </p:grpSpPr>
+      <p:sp>
+        <p:nvSpPr>
+          <p:cNvPr id="2" name="Text 0"/>
+          <p:cNvSpPr/>
+          <p:nvPr/>
+        </p:nvSpPr>
+        <p:spPr>
+          <a:xfrm>
+            <a:off x="640080" y="384048"/>
+            <a:ext cx="10881360" cy="685800"/>
+          </a:xfrm>
+          <a:prstGeom prst="rect">
+            <a:avLst/>
+          </a:prstGeom>
+          <a:noFill/>
+          <a:ln/>
+        </p:spPr>
+        <p:txBody>
+          <a:bodyPr wrap="square" lIns="0" tIns="0" rIns="0" bIns="0" rtlCol="0" anchor="ctr"/>
+          <a:lstStyle/>
+          <a:p>
+            <a:pPr indent="0" marL="0">
+              <a:buNone/>
+            </a:pPr>
+            <a:r>
+              <a:rPr lang="en-US" sz="3400" b="1" dirty="0">
+                <a:solidFill>
+                  <a:srgbClr val="1F2A1F"/>
+                </a:solidFill>
+                <a:latin typeface="Cambria" pitchFamily="34" charset="0"/>
+                <a:ea typeface="Cambria" pitchFamily="34" charset="-122"/>
+                <a:cs typeface="Cambria" pitchFamily="34" charset="-120"/>
+              </a:rPr>
+              <a:t>Comparer à quoi ?</a:t>
+            </a:r>
+            <a:endParaRPr lang="en-US" sz="3400" dirty="0"/>
+          </a:p>
+        </p:txBody>
+      </p:sp>
+      <p:sp>
+        <p:nvSpPr>
+          <p:cNvPr id="3" name="Text 1"/>
+          <p:cNvSpPr/>
+          <p:nvPr/>
+        </p:nvSpPr>
+        <p:spPr>
+          <a:xfrm>
+            <a:off x="640080" y="1078992"/>
+            <a:ext cx="10881360" cy="384048"/>
+          </a:xfrm>
+          <a:prstGeom prst="rect">
+            <a:avLst/>
+          </a:prstGeom>
+          <a:noFill/>
+          <a:ln/>
+        </p:spPr>
+        <p:txBody>
+          <a:bodyPr wrap="square" lIns="0" tIns="0" rIns="0" bIns="0" rtlCol="0" anchor="ctr"/>
+          <a:lstStyle/>
+          <a:p>
+            <a:pPr indent="0" marL="0">
+              <a:buNone/>
+            </a:pPr>
+            <a:r>
+              <a:rPr lang="en-US" sz="1400" i="1" dirty="0">
+                <a:solidFill>
+                  <a:srgbClr val="5E6E5E"/>
+                </a:solidFill>
+                <a:latin typeface="Calibri" pitchFamily="34" charset="0"/>
+                <a:ea typeface="Calibri" pitchFamily="34" charset="-122"/>
+                <a:cs typeface="Calibri" pitchFamily="34" charset="-120"/>
+              </a:rPr>
+              <a:t>Une erreur ne se juge que relativement</a:t>
+            </a:r>
+            <a:endParaRPr lang="en-US" sz="1400" dirty="0"/>
+          </a:p>
+        </p:txBody>
+      </p:sp>
+      <p:sp>
+        <p:nvSpPr>
+          <p:cNvPr id="4" name="Shape 2"/>
+          <p:cNvSpPr/>
+          <p:nvPr/>
+        </p:nvSpPr>
+        <p:spPr>
+          <a:xfrm>
+            <a:off x="640080" y="1737360"/>
+            <a:ext cx="5166360" cy="1828800"/>
+          </a:xfrm>
+          <a:prstGeom prst="roundRect">
+            <a:avLst>
+              <a:gd name="adj" fmla="val 4000"/>
+            </a:avLst>
+          </a:prstGeom>
+          <a:solidFill>
+            <a:srgbClr val="EDF2E6"/>
+          </a:solidFill>
+          <a:ln w="12700">
+            <a:solidFill>
+              <a:srgbClr val="EDF2E6"/>
+            </a:solidFill>
+            <a:prstDash val="solid"/>
+          </a:ln>
+        </p:spPr>
+      </p:sp>
+      <p:sp>
+        <p:nvSpPr>
+          <p:cNvPr id="5" name="Text 3"/>
+          <p:cNvSpPr/>
+          <p:nvPr/>
+        </p:nvSpPr>
+        <p:spPr>
+          <a:xfrm>
+            <a:off x="960120" y="1920240"/>
+            <a:ext cx="4389120" cy="310896"/>
+          </a:xfrm>
+          <a:prstGeom prst="rect">
+            <a:avLst/>
+          </a:prstGeom>
+          <a:noFill/>
+          <a:ln/>
+        </p:spPr>
+        <p:txBody>
+          <a:bodyPr wrap="square" lIns="0" tIns="0" rIns="0" bIns="0" rtlCol="0" anchor="ctr"/>
+          <a:lstStyle/>
+          <a:p>
+            <a:pPr indent="0" marL="0">
+              <a:buNone/>
+            </a:pPr>
+            <a:r>
+              <a:rPr lang="en-US" sz="1700" b="1" dirty="0">
+                <a:solidFill>
+                  <a:srgbClr val="5E6E5E"/>
+                </a:solidFill>
+                <a:latin typeface="Cambria" pitchFamily="34" charset="0"/>
+                <a:ea typeface="Cambria" pitchFamily="34" charset="-122"/>
+                <a:cs typeface="Cambria" pitchFamily="34" charset="-120"/>
+              </a:rPr>
+              <a:t>La référence naïve</a:t>
+            </a:r>
+            <a:endParaRPr lang="en-US" sz="1700" dirty="0"/>
+          </a:p>
+        </p:txBody>
+      </p:sp>
+      <p:sp>
+        <p:nvSpPr>
+          <p:cNvPr id="6" name="Text 4"/>
+          <p:cNvSpPr/>
+          <p:nvPr/>
+        </p:nvSpPr>
+        <p:spPr>
+          <a:xfrm>
+            <a:off x="960120" y="2377440"/>
+            <a:ext cx="4572000" cy="1005840"/>
+          </a:xfrm>
+          <a:prstGeom prst="rect">
+            <a:avLst/>
+          </a:prstGeom>
+          <a:noFill/>
+          <a:ln/>
+        </p:spPr>
+        <p:txBody>
+          <a:bodyPr wrap="square" lIns="0" tIns="0" rIns="0" bIns="0" rtlCol="0" anchor="t"/>
+          <a:lstStyle/>
+          <a:p>
+            <a:pPr indent="0" marL="0">
+              <a:lnSpc>
+                <a:spcPct val="115000"/>
+              </a:lnSpc>
+              <a:buNone/>
+            </a:pPr>
+            <a:r>
+              <a:rPr lang="en-US" sz="1200" dirty="0">
+                <a:solidFill>
+                  <a:srgbClr val="1F2A1F"/>
+                </a:solidFill>
+                <a:latin typeface="Calibri" pitchFamily="34" charset="0"/>
+                <a:ea typeface="Calibri" pitchFamily="34" charset="-122"/>
+                <a:cs typeface="Calibri" pitchFamily="34" charset="-120"/>
+              </a:rPr>
+              <a:t>Prédire la moyenne du parc pour tous les véhicules, sans regarder aucune variable. C'est le modèle le plus bête possible — et le point de départ obligé.</a:t>
+            </a:r>
+            <a:endParaRPr lang="en-US" sz="1200" dirty="0"/>
+          </a:p>
+        </p:txBody>
+      </p:sp>
+      <p:sp>
+        <p:nvSpPr>
+          <p:cNvPr id="7" name="Shape 5"/>
+          <p:cNvSpPr/>
+          <p:nvPr/>
+        </p:nvSpPr>
+        <p:spPr>
+          <a:xfrm>
+            <a:off x="6355080" y="1737360"/>
+            <a:ext cx="5166360" cy="1828800"/>
+          </a:xfrm>
+          <a:prstGeom prst="roundRect">
+            <a:avLst>
+              <a:gd name="adj" fmla="val 4000"/>
+            </a:avLst>
+          </a:prstGeom>
+          <a:solidFill>
+            <a:srgbClr val="1A3A1C"/>
+          </a:solidFill>
+          <a:ln w="12700">
+            <a:solidFill>
+              <a:srgbClr val="1A3A1C"/>
+            </a:solidFill>
+            <a:prstDash val="solid"/>
+          </a:ln>
+        </p:spPr>
+      </p:sp>
+      <p:sp>
+        <p:nvSpPr>
+          <p:cNvPr id="8" name="Text 6"/>
+          <p:cNvSpPr/>
+          <p:nvPr/>
+        </p:nvSpPr>
+        <p:spPr>
+          <a:xfrm>
+            <a:off x="6675120" y="1920240"/>
+            <a:ext cx="4389120" cy="310896"/>
+          </a:xfrm>
+          <a:prstGeom prst="rect">
+            <a:avLst/>
+          </a:prstGeom>
+          <a:noFill/>
+          <a:ln/>
+        </p:spPr>
+        <p:txBody>
+          <a:bodyPr wrap="square" lIns="0" tIns="0" rIns="0" bIns="0" rtlCol="0" anchor="ctr"/>
+          <a:lstStyle/>
+          <a:p>
+            <a:pPr indent="0" marL="0">
+              <a:buNone/>
+            </a:pPr>
+            <a:r>
+              <a:rPr lang="en-US" sz="1700" b="1" dirty="0">
+                <a:solidFill>
+                  <a:srgbClr val="97BC62"/>
+                </a:solidFill>
+                <a:latin typeface="Cambria" pitchFamily="34" charset="0"/>
+                <a:ea typeface="Cambria" pitchFamily="34" charset="-122"/>
+                <a:cs typeface="Cambria" pitchFamily="34" charset="-120"/>
+              </a:rPr>
+              <a:t>Ce qu'elle révèle</a:t>
+            </a:r>
+            <a:endParaRPr lang="en-US" sz="1700" dirty="0"/>
+          </a:p>
+        </p:txBody>
+      </p:sp>
+      <p:sp>
+        <p:nvSpPr>
+          <p:cNvPr id="9" name="Text 7"/>
+          <p:cNvSpPr/>
+          <p:nvPr/>
+        </p:nvSpPr>
+        <p:spPr>
+          <a:xfrm>
+            <a:off x="6675120" y="2377440"/>
+            <a:ext cx="4572000" cy="1005840"/>
+          </a:xfrm>
+          <a:prstGeom prst="rect">
+            <a:avLst/>
+          </a:prstGeom>
+          <a:noFill/>
+          <a:ln/>
+        </p:spPr>
+        <p:txBody>
+          <a:bodyPr wrap="square" lIns="0" tIns="0" rIns="0" bIns="0" rtlCol="0" anchor="ctr"/>
+          <a:lstStyle/>
+          <a:p>
+            <a:pPr indent="0" marL="0">
+              <a:lnSpc>
+                <a:spcPct val="115000"/>
+              </a:lnSpc>
+              <a:buNone/>
+            </a:pPr>
+            <a:r>
+              <a:rPr lang="en-US" sz="1200" dirty="0">
+                <a:solidFill>
+                  <a:srgbClr val="FFFFFF"/>
+                </a:solidFill>
+                <a:latin typeface="Calibri" pitchFamily="34" charset="0"/>
+                <a:ea typeface="Calibri" pitchFamily="34" charset="-122"/>
+                <a:cs typeface="Calibri" pitchFamily="34" charset="-120"/>
+              </a:rPr>
+              <a:t>15,5 g/km d'erreur ne veut rien dire seul. Rapporté à la référence, ça devient un résultat : masse, puissance et boîte divisent l'erreur par 2,8.</a:t>
+            </a:r>
+            <a:endParaRPr lang="en-US" sz="1200" dirty="0"/>
+          </a:p>
+        </p:txBody>
+      </p:sp>
+      <p:sp>
+        <p:nvSpPr>
+          <p:cNvPr id="10" name="Shape 8"/>
+          <p:cNvSpPr/>
+          <p:nvPr/>
+        </p:nvSpPr>
+        <p:spPr>
+          <a:xfrm>
+            <a:off x="640080" y="3794760"/>
+            <a:ext cx="10881360" cy="1051560"/>
+          </a:xfrm>
+          <a:prstGeom prst="roundRect">
+            <a:avLst>
+              <a:gd name="adj" fmla="val 6957"/>
+            </a:avLst>
+          </a:prstGeom>
+          <a:solidFill>
+            <a:srgbClr val="EDF2E6"/>
+          </a:solidFill>
+          <a:ln w="12700">
+            <a:solidFill>
+              <a:srgbClr val="EDF2E6"/>
+            </a:solidFill>
+            <a:prstDash val="solid"/>
+          </a:ln>
+        </p:spPr>
+      </p:sp>
+      <p:sp>
+        <p:nvSpPr>
+          <p:cNvPr id="11" name="Text 9"/>
+          <p:cNvSpPr/>
+          <p:nvPr/>
+        </p:nvSpPr>
+        <p:spPr>
+          <a:xfrm>
+            <a:off x="1005840" y="3931920"/>
+            <a:ext cx="2743200" cy="685800"/>
+          </a:xfrm>
+          <a:prstGeom prst="rect">
+            <a:avLst/>
+          </a:prstGeom>
+          <a:noFill/>
+          <a:ln/>
+        </p:spPr>
+        <p:txBody>
+          <a:bodyPr wrap="square" lIns="0" tIns="0" rIns="0" bIns="0" rtlCol="0" anchor="ctr"/>
+          <a:lstStyle/>
+          <a:p>
+            <a:pPr indent="0" marL="0">
+              <a:buNone/>
+            </a:pPr>
+            <a:r>
+              <a:rPr lang="en-US" sz="3200" b="1" dirty="0">
+                <a:solidFill>
+                  <a:srgbClr val="5E6E5E"/>
+                </a:solidFill>
+                <a:latin typeface="Cambria" pitchFamily="34" charset="0"/>
+                <a:ea typeface="Cambria" pitchFamily="34" charset="-122"/>
+                <a:cs typeface="Cambria" pitchFamily="34" charset="-120"/>
+              </a:rPr>
+              <a:t>42,9 g/km</a:t>
+            </a:r>
+            <a:endParaRPr lang="en-US" sz="3200" dirty="0"/>
+          </a:p>
+        </p:txBody>
+      </p:sp>
+      <p:sp>
+        <p:nvSpPr>
+          <p:cNvPr id="12" name="Text 10"/>
+          <p:cNvSpPr/>
+          <p:nvPr/>
+        </p:nvSpPr>
+        <p:spPr>
+          <a:xfrm>
+            <a:off x="1005840" y="4526280"/>
+            <a:ext cx="3108960" cy="274320"/>
+          </a:xfrm>
+          <a:prstGeom prst="rect">
+            <a:avLst/>
+          </a:prstGeom>
+          <a:noFill/>
+          <a:ln/>
+        </p:spPr>
+        <p:txBody>
+          <a:bodyPr wrap="square" lIns="0" tIns="0" rIns="0" bIns="0" rtlCol="0" anchor="ctr"/>
+          <a:lstStyle/>
+          <a:p>
+            <a:pPr indent="0" marL="0">
+              <a:buNone/>
+            </a:pPr>
+            <a:r>
+              <a:rPr lang="en-US" sz="1150" dirty="0">
+                <a:solidFill>
+                  <a:srgbClr val="5E6E5E"/>
+                </a:solidFill>
+                <a:latin typeface="Calibri" pitchFamily="34" charset="0"/>
+                <a:ea typeface="Calibri" pitchFamily="34" charset="-122"/>
+                <a:cs typeface="Calibri" pitchFamily="34" charset="-120"/>
+              </a:rPr>
+              <a:t>erreur de la référence naïve</a:t>
+            </a:r>
+            <a:endParaRPr lang="en-US" sz="1150" dirty="0"/>
+          </a:p>
+        </p:txBody>
+      </p:sp>
+      <p:sp>
+        <p:nvSpPr>
+          <p:cNvPr id="13" name="Text 11"/>
+          <p:cNvSpPr/>
+          <p:nvPr/>
+        </p:nvSpPr>
+        <p:spPr>
+          <a:xfrm>
+            <a:off x="4480560" y="4023360"/>
+            <a:ext cx="731520" cy="457200"/>
+          </a:xfrm>
+          <a:prstGeom prst="rect">
+            <a:avLst/>
+          </a:prstGeom>
+          <a:noFill/>
+          <a:ln/>
+        </p:spPr>
+        <p:txBody>
+          <a:bodyPr wrap="square" lIns="0" tIns="0" rIns="0" bIns="0" rtlCol="0" anchor="ctr"/>
+          <a:lstStyle/>
+          <a:p>
+            <a:pPr algn="ctr" indent="0" marL="0">
+              <a:buNone/>
+            </a:pPr>
+            <a:r>
+              <a:rPr lang="en-US" sz="2600" b="1" dirty="0">
+                <a:solidFill>
+                  <a:srgbClr val="97BC62"/>
+                </a:solidFill>
+                <a:latin typeface="Calibri" pitchFamily="34" charset="0"/>
+                <a:ea typeface="Calibri" pitchFamily="34" charset="-122"/>
+                <a:cs typeface="Calibri" pitchFamily="34" charset="-120"/>
+              </a:rPr>
+              <a:t>→</a:t>
+            </a:r>
+            <a:endParaRPr lang="en-US" sz="2600" dirty="0"/>
+          </a:p>
+        </p:txBody>
+      </p:sp>
+      <p:sp>
+        <p:nvSpPr>
+          <p:cNvPr id="14" name="Text 12"/>
+          <p:cNvSpPr/>
+          <p:nvPr/>
+        </p:nvSpPr>
+        <p:spPr>
+          <a:xfrm>
+            <a:off x="5669280" y="3931920"/>
+            <a:ext cx="2743200" cy="685800"/>
+          </a:xfrm>
+          <a:prstGeom prst="rect">
+            <a:avLst/>
+          </a:prstGeom>
+          <a:noFill/>
+          <a:ln/>
+        </p:spPr>
+        <p:txBody>
+          <a:bodyPr wrap="square" lIns="0" tIns="0" rIns="0" bIns="0" rtlCol="0" anchor="ctr"/>
+          <a:lstStyle/>
+          <a:p>
+            <a:pPr indent="0" marL="0">
+              <a:buNone/>
+            </a:pPr>
+            <a:r>
+              <a:rPr lang="en-US" sz="3200" b="1" dirty="0">
+                <a:solidFill>
+                  <a:srgbClr val="2C5F2D"/>
+                </a:solidFill>
+                <a:latin typeface="Cambria" pitchFamily="34" charset="0"/>
+                <a:ea typeface="Cambria" pitchFamily="34" charset="-122"/>
+                <a:cs typeface="Cambria" pitchFamily="34" charset="-120"/>
+              </a:rPr>
+              <a:t>15,5 g/km</a:t>
+            </a:r>
+            <a:endParaRPr lang="en-US" sz="3200" dirty="0"/>
+          </a:p>
+        </p:txBody>
+      </p:sp>
+      <p:sp>
+        <p:nvSpPr>
+          <p:cNvPr id="15" name="Text 13"/>
+          <p:cNvSpPr/>
+          <p:nvPr/>
+        </p:nvSpPr>
+        <p:spPr>
+          <a:xfrm>
+            <a:off x="5669280" y="4526280"/>
+            <a:ext cx="5029200" cy="274320"/>
+          </a:xfrm>
+          <a:prstGeom prst="rect">
+            <a:avLst/>
+          </a:prstGeom>
+          <a:noFill/>
+          <a:ln/>
+        </p:spPr>
+        <p:txBody>
+          <a:bodyPr wrap="square" lIns="0" tIns="0" rIns="0" bIns="0" rtlCol="0" anchor="ctr"/>
+          <a:lstStyle/>
+          <a:p>
+            <a:pPr indent="0" marL="0">
+              <a:buNone/>
+            </a:pPr>
+            <a:r>
+              <a:rPr lang="en-US" sz="1150" dirty="0">
+                <a:solidFill>
+                  <a:srgbClr val="1F2A1F"/>
+                </a:solidFill>
+                <a:latin typeface="Calibri" pitchFamily="34" charset="0"/>
+                <a:ea typeface="Calibri" pitchFamily="34" charset="-122"/>
+                <a:cs typeface="Calibri" pitchFamily="34" charset="-120"/>
+              </a:rPr>
+              <a:t>erreur du modèle, sur le jeu de test</a:t>
+            </a:r>
+            <a:endParaRPr lang="en-US" sz="1150" dirty="0"/>
+          </a:p>
+        </p:txBody>
+      </p:sp>
+      <p:sp>
+        <p:nvSpPr>
+          <p:cNvPr id="16" name="Shape 14"/>
+          <p:cNvSpPr/>
+          <p:nvPr/>
+        </p:nvSpPr>
+        <p:spPr>
+          <a:xfrm>
+            <a:off x="640080" y="5074920"/>
+            <a:ext cx="10881360" cy="777240"/>
+          </a:xfrm>
+          <a:prstGeom prst="roundRect">
+            <a:avLst>
+              <a:gd name="adj" fmla="val 9412"/>
+            </a:avLst>
+          </a:prstGeom>
+          <a:solidFill>
+            <a:srgbClr val="EDF2E6"/>
+          </a:solidFill>
+          <a:ln w="12700">
+            <a:solidFill>
+              <a:srgbClr val="EDF2E6"/>
+            </a:solidFill>
+            <a:prstDash val="solid"/>
+          </a:ln>
+        </p:spPr>
+      </p:sp>
+      <p:sp>
+        <p:nvSpPr>
+          <p:cNvPr id="17" name="Text 15"/>
+          <p:cNvSpPr/>
+          <p:nvPr/>
+        </p:nvSpPr>
+        <p:spPr>
+          <a:xfrm>
+            <a:off x="960120" y="5193792"/>
+            <a:ext cx="10241280" cy="548640"/>
+          </a:xfrm>
+          <a:prstGeom prst="rect">
+            <a:avLst/>
+          </a:prstGeom>
+          <a:noFill/>
+          <a:ln/>
+        </p:spPr>
+        <p:txBody>
+          <a:bodyPr wrap="square" lIns="0" tIns="0" rIns="0" bIns="0" rtlCol="0" anchor="ctr"/>
+          <a:lstStyle/>
+          <a:p>
+            <a:pPr indent="0" marL="0">
+              <a:buNone/>
+            </a:pPr>
+            <a:r>
+              <a:rPr lang="en-US" sz="1300" dirty="0">
+                <a:solidFill>
+                  <a:srgbClr val="1F2A1F"/>
+                </a:solidFill>
+                <a:latin typeface="Calibri" pitchFamily="34" charset="0"/>
+                <a:ea typeface="Calibri" pitchFamily="34" charset="-122"/>
+                <a:cs typeface="Calibri" pitchFamily="34" charset="-120"/>
+              </a:rPr>
+              <a:t>Même réflexe en classification : la classe majoritaire. Un modèle qui ne bat pas la référence naïve n'a rien appris.</a:t>
+            </a:r>
+            <a:endParaRPr lang="en-US" sz="1300" dirty="0"/>
+          </a:p>
+        </p:txBody>
+      </p:sp>
+    </p:spTree>
+  </p:cSld>
+  <p:clrMapOvr>
+    <a:masterClrMapping/>
+  </p:clrMapOvr>
+</p:sld>
+</file>
+
+<file path=ppt/slides/slide21.xml><?xml version="1.0" encoding="utf-8"?>
+<p:sld xmlns:a="http://schemas.openxmlformats.org/drawingml/2006/main" xmlns:r="http://schemas.openxmlformats.org/officeDocument/2006/relationships" xmlns:p="http://schemas.openxmlformats.org/presentationml/2006/main">
+  <p:cSld name="Slide 2">
+    <p:spTree>
+      <p:nvGrpSpPr>
+        <p:cNvPr id="1" name=""/>
+        <p:cNvGrpSpPr/>
+        <p:nvPr/>
+      </p:nvGrpSpPr>
+      <p:grpSpPr>
+        <a:xfrm>
+          <a:off x="0" y="0"/>
+          <a:ext cx="0" cy="0"/>
+          <a:chOff x="0" y="0"/>
+          <a:chExt cx="0" cy="0"/>
+        </a:xfrm>
+      </p:grpSpPr>
+      <p:sp>
+        <p:nvSpPr>
+          <p:cNvPr id="2" name="Text 0"/>
+          <p:cNvSpPr/>
+          <p:nvPr/>
+        </p:nvSpPr>
+        <p:spPr>
+          <a:xfrm>
+            <a:off x="640080" y="384048"/>
+            <a:ext cx="10881360" cy="685800"/>
+          </a:xfrm>
+          <a:prstGeom prst="rect">
+            <a:avLst/>
+          </a:prstGeom>
+          <a:noFill/>
+          <a:ln/>
+        </p:spPr>
+        <p:txBody>
+          <a:bodyPr wrap="square" lIns="0" tIns="0" rIns="0" bIns="0" rtlCol="0" anchor="ctr"/>
+          <a:lstStyle/>
+          <a:p>
+            <a:pPr indent="0" marL="0">
+              <a:buNone/>
+            </a:pPr>
+            <a:r>
+              <a:rPr lang="en-US" sz="3400" b="1" dirty="0">
+                <a:solidFill>
+                  <a:srgbClr val="1F2A1F"/>
+                </a:solidFill>
+                <a:latin typeface="Cambria" pitchFamily="34" charset="0"/>
+                <a:ea typeface="Cambria" pitchFamily="34" charset="-122"/>
+                <a:cs typeface="Cambria" pitchFamily="34" charset="-120"/>
+              </a:rPr>
+              <a:t>Les résidus, deuxième lecture</a:t>
+            </a:r>
+            <a:endParaRPr lang="en-US" sz="3400" dirty="0"/>
+          </a:p>
+        </p:txBody>
+      </p:sp>
+      <p:sp>
+        <p:nvSpPr>
+          <p:cNvPr id="3" name="Text 1"/>
+          <p:cNvSpPr/>
+          <p:nvPr/>
+        </p:nvSpPr>
+        <p:spPr>
+          <a:xfrm>
+            <a:off x="640080" y="1078992"/>
+            <a:ext cx="10881360" cy="384048"/>
+          </a:xfrm>
+          <a:prstGeom prst="rect">
+            <a:avLst/>
+          </a:prstGeom>
+          <a:noFill/>
+          <a:ln/>
+        </p:spPr>
+        <p:txBody>
+          <a:bodyPr wrap="square" lIns="0" tIns="0" rIns="0" bIns="0" rtlCol="0" anchor="ctr"/>
+          <a:lstStyle/>
+          <a:p>
+            <a:pPr indent="0" marL="0">
+              <a:buNone/>
+            </a:pPr>
+            <a:r>
+              <a:rPr lang="en-US" sz="1400" i="1" dirty="0">
+                <a:solidFill>
+                  <a:srgbClr val="5E6E5E"/>
+                </a:solidFill>
+                <a:latin typeface="Calibri" pitchFamily="34" charset="0"/>
+                <a:ea typeface="Calibri" pitchFamily="34" charset="-122"/>
+                <a:cs typeface="Calibri" pitchFamily="34" charset="-120"/>
+              </a:rPr>
+              <a:t>Ce que le nuage dit quand on sait quoi y chercher</a:t>
+            </a:r>
+            <a:endParaRPr lang="en-US" sz="1400" dirty="0"/>
+          </a:p>
+        </p:txBody>
+      </p:sp>
+      <p:sp>
+        <p:nvSpPr>
+          <p:cNvPr id="4" name="Shape 2"/>
+          <p:cNvSpPr/>
+          <p:nvPr/>
+        </p:nvSpPr>
+        <p:spPr>
+          <a:xfrm>
+            <a:off x="640080" y="1691640"/>
+            <a:ext cx="5166360" cy="1920240"/>
+          </a:xfrm>
+          <a:prstGeom prst="roundRect">
+            <a:avLst>
+              <a:gd name="adj" fmla="val 3810"/>
+            </a:avLst>
+          </a:prstGeom>
+          <a:solidFill>
+            <a:srgbClr val="EDF2E6"/>
+          </a:solidFill>
+          <a:ln w="12700">
+            <a:solidFill>
+              <a:srgbClr val="EDF2E6"/>
+            </a:solidFill>
+            <a:prstDash val="solid"/>
+          </a:ln>
+        </p:spPr>
+      </p:sp>
+      <p:sp>
+        <p:nvSpPr>
+          <p:cNvPr id="5" name="Shape 3"/>
+          <p:cNvSpPr/>
+          <p:nvPr/>
+        </p:nvSpPr>
+        <p:spPr>
+          <a:xfrm>
+            <a:off x="932688" y="1984248"/>
+            <a:ext cx="420624" cy="420624"/>
+          </a:xfrm>
+          <a:prstGeom prst="ellipse">
+            <a:avLst/>
+          </a:prstGeom>
+          <a:solidFill>
+            <a:srgbClr val="2C5F2D"/>
+          </a:solidFill>
+          <a:ln w="12700">
+            <a:solidFill>
+              <a:srgbClr val="2C5F2D"/>
+            </a:solidFill>
+            <a:prstDash val="solid"/>
+          </a:ln>
+        </p:spPr>
+      </p:sp>
+      <p:sp>
+        <p:nvSpPr>
+          <p:cNvPr id="6" name="Text 4"/>
+          <p:cNvSpPr/>
+          <p:nvPr/>
+        </p:nvSpPr>
+        <p:spPr>
+          <a:xfrm>
+            <a:off x="932688" y="1984248"/>
+            <a:ext cx="420624" cy="420624"/>
+          </a:xfrm>
+          <a:prstGeom prst="rect">
+            <a:avLst/>
+          </a:prstGeom>
+          <a:noFill/>
+          <a:ln/>
+        </p:spPr>
+        <p:txBody>
+          <a:bodyPr wrap="square" lIns="0" tIns="0" rIns="0" bIns="0" rtlCol="0" anchor="ctr"/>
+          <a:lstStyle/>
+          <a:p>
+            <a:pPr algn="ctr" indent="0" marL="0">
+              <a:buNone/>
+            </a:pPr>
+            <a:r>
+              <a:rPr lang="en-US" sz="1500" b="1" dirty="0">
+                <a:solidFill>
+                  <a:srgbClr val="FFFFFF"/>
+                </a:solidFill>
+                <a:latin typeface="Calibri" pitchFamily="34" charset="0"/>
+                <a:ea typeface="Calibri" pitchFamily="34" charset="-122"/>
+                <a:cs typeface="Calibri" pitchFamily="34" charset="-120"/>
+              </a:rPr>
+              <a:t>1</a:t>
+            </a:r>
+            <a:endParaRPr lang="en-US" sz="1500" dirty="0"/>
+          </a:p>
+        </p:txBody>
+      </p:sp>
+      <p:sp>
+        <p:nvSpPr>
+          <p:cNvPr id="7" name="Text 5"/>
+          <p:cNvSpPr/>
+          <p:nvPr/>
+        </p:nvSpPr>
+        <p:spPr>
+          <a:xfrm>
+            <a:off x="1508760" y="2002536"/>
+            <a:ext cx="4023360" cy="310896"/>
+          </a:xfrm>
+          <a:prstGeom prst="rect">
+            <a:avLst/>
+          </a:prstGeom>
+          <a:noFill/>
+          <a:ln/>
+        </p:spPr>
+        <p:txBody>
+          <a:bodyPr wrap="square" lIns="0" tIns="0" rIns="0" bIns="0" rtlCol="0" anchor="ctr"/>
+          <a:lstStyle/>
+          <a:p>
+            <a:pPr indent="0" marL="0">
+              <a:buNone/>
+            </a:pPr>
+            <a:r>
+              <a:rPr lang="en-US" sz="1700" b="1" dirty="0">
+                <a:solidFill>
+                  <a:srgbClr val="2C5F2D"/>
+                </a:solidFill>
+                <a:latin typeface="Cambria" pitchFamily="34" charset="0"/>
+                <a:ea typeface="Cambria" pitchFamily="34" charset="-122"/>
+                <a:cs typeface="Cambria" pitchFamily="34" charset="-120"/>
+              </a:rPr>
+              <a:t>La dispersion s'évase</a:t>
+            </a:r>
+            <a:endParaRPr lang="en-US" sz="1700" dirty="0"/>
+          </a:p>
+        </p:txBody>
+      </p:sp>
+      <p:sp>
+        <p:nvSpPr>
+          <p:cNvPr id="8" name="Text 6"/>
+          <p:cNvSpPr/>
+          <p:nvPr/>
+        </p:nvSpPr>
+        <p:spPr>
+          <a:xfrm>
+            <a:off x="932688" y="2606040"/>
+            <a:ext cx="4572000" cy="868680"/>
+          </a:xfrm>
+          <a:prstGeom prst="rect">
+            <a:avLst/>
+          </a:prstGeom>
+          <a:noFill/>
+          <a:ln/>
+        </p:spPr>
+        <p:txBody>
+          <a:bodyPr wrap="square" lIns="0" tIns="0" rIns="0" bIns="0" rtlCol="0" anchor="t"/>
+          <a:lstStyle/>
+          <a:p>
+            <a:pPr indent="0" marL="0">
+              <a:lnSpc>
+                <a:spcPct val="115000"/>
+              </a:lnSpc>
+              <a:buNone/>
+            </a:pPr>
+            <a:r>
+              <a:rPr lang="en-US" sz="1300" dirty="0">
+                <a:solidFill>
+                  <a:srgbClr val="1F2A1F"/>
+                </a:solidFill>
+                <a:latin typeface="Calibri" pitchFamily="34" charset="0"/>
+                <a:ea typeface="Calibri" pitchFamily="34" charset="-122"/>
+                <a:cs typeface="Calibri" pitchFamily="34" charset="-120"/>
+              </a:rPr>
+              <a:t>L'erreur passe de 11,7 g/km en bas de gamme à 30,0 au-dessus de 300 kW. L'incertitude dépend du véhicule — le R² ne le dit pas.</a:t>
+            </a:r>
+            <a:endParaRPr lang="en-US" sz="1300" dirty="0"/>
+          </a:p>
+        </p:txBody>
+      </p:sp>
+      <p:sp>
+        <p:nvSpPr>
+          <p:cNvPr id="9" name="Shape 7"/>
+          <p:cNvSpPr/>
+          <p:nvPr/>
+        </p:nvSpPr>
+        <p:spPr>
+          <a:xfrm>
+            <a:off x="6355080" y="1691640"/>
+            <a:ext cx="5166360" cy="1920240"/>
+          </a:xfrm>
+          <a:prstGeom prst="roundRect">
+            <a:avLst>
+              <a:gd name="adj" fmla="val 3810"/>
+            </a:avLst>
+          </a:prstGeom>
+          <a:solidFill>
+            <a:srgbClr val="EDF2E6"/>
+          </a:solidFill>
+          <a:ln w="12700">
+            <a:solidFill>
+              <a:srgbClr val="EDF2E6"/>
+            </a:solidFill>
+            <a:prstDash val="solid"/>
+          </a:ln>
+        </p:spPr>
+      </p:sp>
+      <p:sp>
+        <p:nvSpPr>
+          <p:cNvPr id="10" name="Shape 8"/>
+          <p:cNvSpPr/>
+          <p:nvPr/>
+        </p:nvSpPr>
+        <p:spPr>
+          <a:xfrm>
+            <a:off x="6647688" y="1984248"/>
+            <a:ext cx="420624" cy="420624"/>
+          </a:xfrm>
+          <a:prstGeom prst="ellipse">
+            <a:avLst/>
+          </a:prstGeom>
+          <a:solidFill>
+            <a:srgbClr val="2C5F2D"/>
+          </a:solidFill>
+          <a:ln w="12700">
+            <a:solidFill>
+              <a:srgbClr val="2C5F2D"/>
+            </a:solidFill>
+            <a:prstDash val="solid"/>
+          </a:ln>
+        </p:spPr>
+      </p:sp>
+      <p:sp>
+        <p:nvSpPr>
+          <p:cNvPr id="11" name="Text 9"/>
+          <p:cNvSpPr/>
+          <p:nvPr/>
+        </p:nvSpPr>
+        <p:spPr>
+          <a:xfrm>
+            <a:off x="6647688" y="1984248"/>
+            <a:ext cx="420624" cy="420624"/>
+          </a:xfrm>
+          <a:prstGeom prst="rect">
+            <a:avLst/>
+          </a:prstGeom>
+          <a:noFill/>
+          <a:ln/>
+        </p:spPr>
+        <p:txBody>
+          <a:bodyPr wrap="square" lIns="0" tIns="0" rIns="0" bIns="0" rtlCol="0" anchor="ctr"/>
+          <a:lstStyle/>
+          <a:p>
+            <a:pPr algn="ctr" indent="0" marL="0">
+              <a:buNone/>
+            </a:pPr>
+            <a:r>
+              <a:rPr lang="en-US" sz="1500" b="1" dirty="0">
+                <a:solidFill>
+                  <a:srgbClr val="FFFFFF"/>
+                </a:solidFill>
+                <a:latin typeface="Calibri" pitchFamily="34" charset="0"/>
+                <a:ea typeface="Calibri" pitchFamily="34" charset="-122"/>
+                <a:cs typeface="Calibri" pitchFamily="34" charset="-120"/>
+              </a:rPr>
+              <a:t>2</a:t>
+            </a:r>
+            <a:endParaRPr lang="en-US" sz="1500" dirty="0"/>
+          </a:p>
+        </p:txBody>
+      </p:sp>
+      <p:sp>
+        <p:nvSpPr>
+          <p:cNvPr id="12" name="Text 10"/>
+          <p:cNvSpPr/>
+          <p:nvPr/>
+        </p:nvSpPr>
+        <p:spPr>
+          <a:xfrm>
+            <a:off x="7223760" y="2002536"/>
+            <a:ext cx="4023360" cy="310896"/>
+          </a:xfrm>
+          <a:prstGeom prst="rect">
+            <a:avLst/>
+          </a:prstGeom>
+          <a:noFill/>
+          <a:ln/>
+        </p:spPr>
+        <p:txBody>
+          <a:bodyPr wrap="square" lIns="0" tIns="0" rIns="0" bIns="0" rtlCol="0" anchor="ctr"/>
+          <a:lstStyle/>
+          <a:p>
+            <a:pPr indent="0" marL="0">
+              <a:buNone/>
+            </a:pPr>
+            <a:r>
+              <a:rPr lang="en-US" sz="1700" b="1" dirty="0">
+                <a:solidFill>
+                  <a:srgbClr val="2C5F2D"/>
+                </a:solidFill>
+                <a:latin typeface="Cambria" pitchFamily="34" charset="0"/>
+                <a:ea typeface="Cambria" pitchFamily="34" charset="-122"/>
+                <a:cs typeface="Cambria" pitchFamily="34" charset="-120"/>
+              </a:rPr>
+              <a:t>La traînée est d'un seul côté</a:t>
+            </a:r>
+            <a:endParaRPr lang="en-US" sz="1700" dirty="0"/>
+          </a:p>
+        </p:txBody>
+      </p:sp>
+      <p:sp>
+        <p:nvSpPr>
+          <p:cNvPr id="13" name="Text 11"/>
+          <p:cNvSpPr/>
+          <p:nvPr/>
+        </p:nvSpPr>
+        <p:spPr>
+          <a:xfrm>
+            <a:off x="6647688" y="2606040"/>
+            <a:ext cx="4572000" cy="868680"/>
+          </a:xfrm>
+          <a:prstGeom prst="rect">
+            <a:avLst/>
+          </a:prstGeom>
+          <a:noFill/>
+          <a:ln/>
+        </p:spPr>
+        <p:txBody>
+          <a:bodyPr wrap="square" lIns="0" tIns="0" rIns="0" bIns="0" rtlCol="0" anchor="t"/>
+          <a:lstStyle/>
+          <a:p>
+            <a:pPr indent="0" marL="0">
+              <a:lnSpc>
+                <a:spcPct val="115000"/>
+              </a:lnSpc>
+              <a:buNone/>
+            </a:pPr>
+            <a:r>
+              <a:rPr lang="en-US" sz="1300" dirty="0">
+                <a:solidFill>
+                  <a:srgbClr val="1F2A1F"/>
+                </a:solidFill>
+                <a:latin typeface="Calibri" pitchFamily="34" charset="0"/>
+                <a:ea typeface="Calibri" pitchFamily="34" charset="-122"/>
+                <a:cs typeface="Calibri" pitchFamily="34" charset="-120"/>
+              </a:rPr>
+              <a:t>Les vingt plus gros résidus sont tous positifs. Le modèle sous-estime sans jamais surestimer autant : signature d'une variable manquante.</a:t>
+            </a:r>
+            <a:endParaRPr lang="en-US" sz="1300" dirty="0"/>
+          </a:p>
+        </p:txBody>
+      </p:sp>
+      <p:sp>
+        <p:nvSpPr>
+          <p:cNvPr id="14" name="Shape 12"/>
+          <p:cNvSpPr/>
+          <p:nvPr/>
+        </p:nvSpPr>
+        <p:spPr>
+          <a:xfrm>
+            <a:off x="640080" y="3977640"/>
+            <a:ext cx="5166360" cy="1920240"/>
+          </a:xfrm>
+          <a:prstGeom prst="roundRect">
+            <a:avLst>
+              <a:gd name="adj" fmla="val 3810"/>
+            </a:avLst>
+          </a:prstGeom>
+          <a:solidFill>
+            <a:srgbClr val="EDF2E6"/>
+          </a:solidFill>
+          <a:ln w="12700">
+            <a:solidFill>
+              <a:srgbClr val="EDF2E6"/>
+            </a:solidFill>
+            <a:prstDash val="solid"/>
+          </a:ln>
+        </p:spPr>
+      </p:sp>
+      <p:sp>
+        <p:nvSpPr>
+          <p:cNvPr id="15" name="Shape 13"/>
+          <p:cNvSpPr/>
+          <p:nvPr/>
+        </p:nvSpPr>
+        <p:spPr>
+          <a:xfrm>
+            <a:off x="932688" y="4270248"/>
+            <a:ext cx="420624" cy="420624"/>
+          </a:xfrm>
+          <a:prstGeom prst="ellipse">
+            <a:avLst/>
+          </a:prstGeom>
+          <a:solidFill>
+            <a:srgbClr val="2C5F2D"/>
+          </a:solidFill>
+          <a:ln w="12700">
+            <a:solidFill>
+              <a:srgbClr val="2C5F2D"/>
+            </a:solidFill>
+            <a:prstDash val="solid"/>
+          </a:ln>
+        </p:spPr>
+      </p:sp>
+      <p:sp>
+        <p:nvSpPr>
+          <p:cNvPr id="16" name="Text 14"/>
+          <p:cNvSpPr/>
+          <p:nvPr/>
+        </p:nvSpPr>
+        <p:spPr>
+          <a:xfrm>
+            <a:off x="932688" y="4270248"/>
+            <a:ext cx="420624" cy="420624"/>
+          </a:xfrm>
+          <a:prstGeom prst="rect">
+            <a:avLst/>
+          </a:prstGeom>
+          <a:noFill/>
+          <a:ln/>
+        </p:spPr>
+        <p:txBody>
+          <a:bodyPr wrap="square" lIns="0" tIns="0" rIns="0" bIns="0" rtlCol="0" anchor="ctr"/>
+          <a:lstStyle/>
+          <a:p>
+            <a:pPr algn="ctr" indent="0" marL="0">
+              <a:buNone/>
+            </a:pPr>
+            <a:r>
+              <a:rPr lang="en-US" sz="1500" b="1" dirty="0">
+                <a:solidFill>
+                  <a:srgbClr val="FFFFFF"/>
+                </a:solidFill>
+                <a:latin typeface="Calibri" pitchFamily="34" charset="0"/>
+                <a:ea typeface="Calibri" pitchFamily="34" charset="-122"/>
+                <a:cs typeface="Calibri" pitchFamily="34" charset="-120"/>
+              </a:rPr>
+              <a:t>3</a:t>
+            </a:r>
+            <a:endParaRPr lang="en-US" sz="1500" dirty="0"/>
+          </a:p>
+        </p:txBody>
+      </p:sp>
+      <p:sp>
+        <p:nvSpPr>
+          <p:cNvPr id="17" name="Text 15"/>
+          <p:cNvSpPr/>
+          <p:nvPr/>
+        </p:nvSpPr>
+        <p:spPr>
+          <a:xfrm>
+            <a:off x="1508760" y="4288536"/>
+            <a:ext cx="4023360" cy="310896"/>
+          </a:xfrm>
+          <a:prstGeom prst="rect">
+            <a:avLst/>
+          </a:prstGeom>
+          <a:noFill/>
+          <a:ln/>
+        </p:spPr>
+        <p:txBody>
+          <a:bodyPr wrap="square" lIns="0" tIns="0" rIns="0" bIns="0" rtlCol="0" anchor="ctr"/>
+          <a:lstStyle/>
+          <a:p>
+            <a:pPr indent="0" marL="0">
+              <a:buNone/>
+            </a:pPr>
+            <a:r>
+              <a:rPr lang="en-US" sz="1700" b="1" dirty="0">
+                <a:solidFill>
+                  <a:srgbClr val="2C5F2D"/>
+                </a:solidFill>
+                <a:latin typeface="Cambria" pitchFamily="34" charset="0"/>
+                <a:ea typeface="Cambria" pitchFamily="34" charset="-122"/>
+                <a:cs typeface="Cambria" pitchFamily="34" charset="-120"/>
+              </a:rPr>
+              <a:t>Une courbure peut rester</a:t>
+            </a:r>
+            <a:endParaRPr lang="en-US" sz="1700" dirty="0"/>
+          </a:p>
+        </p:txBody>
+      </p:sp>
+      <p:sp>
+        <p:nvSpPr>
+          <p:cNvPr id="18" name="Text 16"/>
+          <p:cNvSpPr/>
+          <p:nvPr/>
+        </p:nvSpPr>
+        <p:spPr>
+          <a:xfrm>
+            <a:off x="932688" y="4892040"/>
+            <a:ext cx="4572000" cy="868680"/>
+          </a:xfrm>
+          <a:prstGeom prst="rect">
+            <a:avLst/>
+          </a:prstGeom>
+          <a:noFill/>
+          <a:ln/>
+        </p:spPr>
+        <p:txBody>
+          <a:bodyPr wrap="square" lIns="0" tIns="0" rIns="0" bIns="0" rtlCol="0" anchor="t"/>
+          <a:lstStyle/>
+          <a:p>
+            <a:pPr indent="0" marL="0">
+              <a:lnSpc>
+                <a:spcPct val="115000"/>
+              </a:lnSpc>
+              <a:buNone/>
+            </a:pPr>
+            <a:r>
+              <a:rPr lang="en-US" sz="1300" dirty="0">
+                <a:solidFill>
+                  <a:srgbClr val="1F2A1F"/>
+                </a:solidFill>
+                <a:latin typeface="Calibri" pitchFamily="34" charset="0"/>
+                <a:ea typeface="Calibri" pitchFamily="34" charset="-122"/>
+                <a:cs typeface="Calibri" pitchFamily="34" charset="-120"/>
+              </a:rPr>
+              <a:t>Moyenne des résidus par décile de prédiction. Un motif en U = non-linéarité non captée. L'œil seul surinterprète les nuages denses.</a:t>
+            </a:r>
+            <a:endParaRPr lang="en-US" sz="1300" dirty="0"/>
+          </a:p>
+        </p:txBody>
+      </p:sp>
+      <p:sp>
+        <p:nvSpPr>
+          <p:cNvPr id="19" name="Shape 17"/>
+          <p:cNvSpPr/>
+          <p:nvPr/>
+        </p:nvSpPr>
+        <p:spPr>
+          <a:xfrm>
+            <a:off x="6355080" y="3977640"/>
+            <a:ext cx="5166360" cy="1920240"/>
+          </a:xfrm>
+          <a:prstGeom prst="roundRect">
+            <a:avLst>
+              <a:gd name="adj" fmla="val 3810"/>
+            </a:avLst>
+          </a:prstGeom>
+          <a:solidFill>
+            <a:srgbClr val="EDF2E6"/>
+          </a:solidFill>
+          <a:ln w="12700">
+            <a:solidFill>
+              <a:srgbClr val="EDF2E6"/>
+            </a:solidFill>
+            <a:prstDash val="solid"/>
+          </a:ln>
+        </p:spPr>
+      </p:sp>
+      <p:sp>
+        <p:nvSpPr>
+          <p:cNvPr id="20" name="Shape 18"/>
+          <p:cNvSpPr/>
+          <p:nvPr/>
+        </p:nvSpPr>
+        <p:spPr>
+          <a:xfrm>
+            <a:off x="6647688" y="4270248"/>
+            <a:ext cx="420624" cy="420624"/>
+          </a:xfrm>
+          <a:prstGeom prst="ellipse">
+            <a:avLst/>
+          </a:prstGeom>
+          <a:solidFill>
+            <a:srgbClr val="2C5F2D"/>
+          </a:solidFill>
+          <a:ln w="12700">
+            <a:solidFill>
+              <a:srgbClr val="2C5F2D"/>
+            </a:solidFill>
+            <a:prstDash val="solid"/>
+          </a:ln>
+        </p:spPr>
+      </p:sp>
+      <p:sp>
+        <p:nvSpPr>
+          <p:cNvPr id="21" name="Text 19"/>
+          <p:cNvSpPr/>
+          <p:nvPr/>
+        </p:nvSpPr>
+        <p:spPr>
+          <a:xfrm>
+            <a:off x="6647688" y="4270248"/>
+            <a:ext cx="420624" cy="420624"/>
+          </a:xfrm>
+          <a:prstGeom prst="rect">
+            <a:avLst/>
+          </a:prstGeom>
+          <a:noFill/>
+          <a:ln/>
+        </p:spPr>
+        <p:txBody>
+          <a:bodyPr wrap="square" lIns="0" tIns="0" rIns="0" bIns="0" rtlCol="0" anchor="ctr"/>
+          <a:lstStyle/>
+          <a:p>
+            <a:pPr algn="ctr" indent="0" marL="0">
+              <a:buNone/>
+            </a:pPr>
+            <a:r>
+              <a:rPr lang="en-US" sz="1500" b="1" dirty="0">
+                <a:solidFill>
+                  <a:srgbClr val="FFFFFF"/>
+                </a:solidFill>
+                <a:latin typeface="Calibri" pitchFamily="34" charset="0"/>
+                <a:ea typeface="Calibri" pitchFamily="34" charset="-122"/>
+                <a:cs typeface="Calibri" pitchFamily="34" charset="-120"/>
+              </a:rPr>
+              <a:t>4</a:t>
+            </a:r>
+            <a:endParaRPr lang="en-US" sz="1500" dirty="0"/>
+          </a:p>
+        </p:txBody>
+      </p:sp>
+      <p:sp>
+        <p:nvSpPr>
+          <p:cNvPr id="22" name="Text 20"/>
+          <p:cNvSpPr/>
+          <p:nvPr/>
+        </p:nvSpPr>
+        <p:spPr>
+          <a:xfrm>
+            <a:off x="7223760" y="4288536"/>
+            <a:ext cx="4023360" cy="310896"/>
+          </a:xfrm>
+          <a:prstGeom prst="rect">
+            <a:avLst/>
+          </a:prstGeom>
+          <a:noFill/>
+          <a:ln/>
+        </p:spPr>
+        <p:txBody>
+          <a:bodyPr wrap="square" lIns="0" tIns="0" rIns="0" bIns="0" rtlCol="0" anchor="ctr"/>
+          <a:lstStyle/>
+          <a:p>
+            <a:pPr indent="0" marL="0">
+              <a:buNone/>
+            </a:pPr>
+            <a:r>
+              <a:rPr lang="en-US" sz="1700" b="1" dirty="0">
+                <a:solidFill>
+                  <a:srgbClr val="2C5F2D"/>
+                </a:solidFill>
+                <a:latin typeface="Cambria" pitchFamily="34" charset="0"/>
+                <a:ea typeface="Cambria" pitchFamily="34" charset="-122"/>
+                <a:cs typeface="Cambria" pitchFamily="34" charset="-120"/>
+              </a:rPr>
+              <a:t>Attention aux zéros mécaniques</a:t>
+            </a:r>
+            <a:endParaRPr lang="en-US" sz="1700" dirty="0"/>
+          </a:p>
+        </p:txBody>
+      </p:sp>
+      <p:sp>
+        <p:nvSpPr>
+          <p:cNvPr id="23" name="Text 21"/>
+          <p:cNvSpPr/>
+          <p:nvPr/>
+        </p:nvSpPr>
+        <p:spPr>
+          <a:xfrm>
+            <a:off x="6647688" y="4892040"/>
+            <a:ext cx="4572000" cy="868680"/>
+          </a:xfrm>
+          <a:prstGeom prst="rect">
+            <a:avLst/>
+          </a:prstGeom>
+          <a:noFill/>
+          <a:ln/>
+        </p:spPr>
+        <p:txBody>
+          <a:bodyPr wrap="square" lIns="0" tIns="0" rIns="0" bIns="0" rtlCol="0" anchor="t"/>
+          <a:lstStyle/>
+          <a:p>
+            <a:pPr indent="0" marL="0">
+              <a:lnSpc>
+                <a:spcPct val="115000"/>
+              </a:lnSpc>
+              <a:buNone/>
+            </a:pPr>
+            <a:r>
+              <a:rPr lang="en-US" sz="1300" dirty="0">
+                <a:solidFill>
+                  <a:srgbClr val="1F2A1F"/>
+                </a:solidFill>
+                <a:latin typeface="Calibri" pitchFamily="34" charset="0"/>
+                <a:ea typeface="Calibri" pitchFamily="34" charset="-122"/>
+                <a:cs typeface="Calibri" pitchFamily="34" charset="-120"/>
+              </a:rPr>
+              <a:t>Le résidu moyen par modalité d'une variable présente dans le modèle est nul par construction. Ça ne démontre rien.</a:t>
             </a:r>
             <a:endParaRPr lang="en-US" sz="1300" dirty="0"/>
           </a:p>

</xml_diff>

<commit_message>
Precise qu'un tableau 1D n'a pas d'orientation
MEMO : l'entree broadcasting disait que (3,) s'applique aux colonnes, ce qui se lit facilement comme (3,) est une colonne. Reformule, et ajoute au paragraphe NumPy les idiomes v[None, :] / v[:, None] ainsi que le cas de @, seule operation qui oriente un 1D. Deck : meme precision sur la slide 5.
</commit_message>
<xml_diff>
--- a/memo-machine-learning.pptx
+++ b/memo-machine-learning.pptx
@@ -13116,7 +13116,7 @@
                 <a:ea typeface="Calibri" pitchFamily="34" charset="-122"/>
                 <a:cs typeface="Calibri" pitchFamily="34" charset="-120"/>
               </a:rPr>
-              <a:t>NumPy aligne les formes en partant de la droite. Compatibles si égales, ou si l'une vaut 1.</a:t>
+              <a:t>NumPy aligne les formes en partant de la droite. Compatibles si égales, ou si l'une vaut 1. Un (3,) n'a pas d'orientation.</a:t>
             </a:r>
             <a:endParaRPr lang="en-US" sz="1150" dirty="0"/>
           </a:p>
@@ -13178,7 +13178,7 @@
                 <a:ea typeface="Courier New" pitchFamily="34" charset="-122"/>
                 <a:cs typeface="Courier New" pitchFamily="34" charset="-120"/>
               </a:rPr>
-              <a:t>(3,4) + (3,)   ✗</a:t>
+              <a:t>(3,4) + (3,)   ✗   → v[:, None]</a:t>
             </a:r>
             <a:endParaRPr lang="en-US" sz="1150" dirty="0"/>
           </a:p>

</xml_diff>

<commit_message>
Documente la composition des pipelines sklearn
</commit_message>
<xml_diff>
--- a/memo-machine-learning.pptx
+++ b/memo-machine-learning.pptx
@@ -22,6 +22,7 @@
     <p:sldId id="267" r:id="rId13"/>
     <p:sldId id="268" r:id="rId14"/>
     <p:sldId id="271" r:id="rId15"/>
+    <p:sldId id="277" r:id="rId28"/>
     <p:sldId id="272" r:id="rId16"/>
     <p:sldId id="273" r:id="rId17"/>
     <p:sldId id="274" r:id="rId18"/>
@@ -10466,6 +10467,569 @@
                 <a:cs typeface="Calibri" pitchFamily="34" charset="-120"/>
               </a:rPr>
               <a:t>Prochaine étape : classification — une cible binaire, une autre fonction de coût, d'autres métriques que le R².</a:t>
+            </a:r>
+            <a:endParaRPr lang="en-US" sz="1250" dirty="0"/>
+          </a:p>
+        </p:txBody>
+      </p:sp>
+    </p:spTree>
+  </p:cSld>
+  <p:clrMapOvr>
+    <a:masterClrMapping/>
+  </p:clrMapOvr>
+</p:sld>
+</file>
+
+<file path=ppt/slides/slide22.xml><?xml version="1.0" encoding="utf-8"?>
+<p:sld xmlns:a="http://schemas.openxmlformats.org/drawingml/2006/main" xmlns:r="http://schemas.openxmlformats.org/officeDocument/2006/relationships" xmlns:p="http://schemas.openxmlformats.org/presentationml/2006/main">
+  <p:cSld name="Slide 12">
+    <p:spTree>
+      <p:nvGrpSpPr>
+        <p:cNvPr id="1" name=""/>
+        <p:cNvGrpSpPr/>
+        <p:nvPr/>
+      </p:nvGrpSpPr>
+      <p:grpSpPr>
+        <a:xfrm>
+          <a:off x="0" y="0"/>
+          <a:ext cx="0" cy="0"/>
+          <a:chOff x="0" y="0"/>
+          <a:chExt cx="0" cy="0"/>
+        </a:xfrm>
+      </p:grpSpPr>
+      <p:sp>
+        <p:nvSpPr>
+          <p:cNvPr id="2" name="Text 0"/>
+          <p:cNvSpPr/>
+          <p:nvPr/>
+        </p:nvSpPr>
+        <p:spPr>
+          <a:xfrm>
+            <a:off x="640080" y="384048"/>
+            <a:ext cx="10881360" cy="685800"/>
+          </a:xfrm>
+          <a:prstGeom prst="rect">
+            <a:avLst/>
+          </a:prstGeom>
+          <a:noFill/>
+          <a:ln/>
+        </p:spPr>
+        <p:txBody>
+          <a:bodyPr wrap="square" lIns="0" tIns="0" rIns="0" bIns="0" rtlCol="0" anchor="ctr"/>
+          <a:lstStyle/>
+          <a:p>
+            <a:pPr marL="0" indent="0">
+              <a:buNone/>
+            </a:pPr>
+            <a:r>
+              <a:rPr lang="en-US" sz="3400" b="1" dirty="0">
+                <a:solidFill>
+                  <a:srgbClr val="1F2A1F"/>
+                </a:solidFill>
+                <a:latin typeface="Cambria" pitchFamily="34" charset="0"/>
+                <a:ea typeface="Cambria" pitchFamily="34" charset="-122"/>
+                <a:cs typeface="Cambria" pitchFamily="34" charset="-120"/>
+              </a:rPr>
+              <a:t>La préparation fait partie du modèle</a:t>
+            </a:r>
+            <a:endParaRPr lang="en-US" sz="3400" dirty="0"/>
+          </a:p>
+        </p:txBody>
+      </p:sp>
+      <p:sp>
+        <p:nvSpPr>
+          <p:cNvPr id="3" name="Text 1"/>
+          <p:cNvSpPr/>
+          <p:nvPr/>
+        </p:nvSpPr>
+        <p:spPr>
+          <a:xfrm>
+            <a:off x="640080" y="1078992"/>
+            <a:ext cx="10881360" cy="384048"/>
+          </a:xfrm>
+          <a:prstGeom prst="rect">
+            <a:avLst/>
+          </a:prstGeom>
+          <a:noFill/>
+          <a:ln/>
+        </p:spPr>
+        <p:txBody>
+          <a:bodyPr wrap="square" lIns="0" tIns="0" rIns="0" bIns="0" rtlCol="0" anchor="ctr"/>
+          <a:lstStyle/>
+          <a:p>
+            <a:pPr marL="0" indent="0">
+              <a:buNone/>
+            </a:pPr>
+            <a:r>
+              <a:rPr lang="en-US" sz="1400" i="1" dirty="0">
+                <a:solidFill>
+                  <a:srgbClr val="5E6E5E"/>
+                </a:solidFill>
+                <a:latin typeface="Calibri" pitchFamily="34" charset="0"/>
+                <a:ea typeface="Calibri" pitchFamily="34" charset="-122"/>
+                <a:cs typeface="Calibri" pitchFamily="34" charset="-120"/>
+              </a:rPr>
+              <a:t>Une fuite peut venir du code, pas seulement des données</a:t>
+            </a:r>
+            <a:endParaRPr lang="en-US" sz="1400" dirty="0"/>
+          </a:p>
+        </p:txBody>
+      </p:sp>
+      <p:sp>
+        <p:nvSpPr>
+          <p:cNvPr id="4" name="Shape 2"/>
+          <p:cNvSpPr/>
+          <p:nvPr/>
+        </p:nvSpPr>
+        <p:spPr>
+          <a:xfrm>
+            <a:off x="640080" y="1737360"/>
+            <a:ext cx="3538728" cy="2377440"/>
+          </a:xfrm>
+          <a:prstGeom prst="roundRect">
+            <a:avLst>
+              <a:gd name="adj" fmla="val 3077"/>
+            </a:avLst>
+          </a:prstGeom>
+          <a:solidFill>
+            <a:srgbClr val="EDF2E6"/>
+          </a:solidFill>
+          <a:ln w="12700">
+            <a:solidFill>
+              <a:srgbClr val="EDF2E6"/>
+            </a:solidFill>
+            <a:prstDash val="solid"/>
+          </a:ln>
+        </p:spPr>
+        <p:txBody>
+          <a:bodyPr/>
+          <a:lstStyle/>
+          <a:p>
+            <a:endParaRPr lang="en-US"/>
+          </a:p>
+        </p:txBody>
+      </p:sp>
+      <p:sp>
+        <p:nvSpPr>
+          <p:cNvPr id="5" name="Text 3"/>
+          <p:cNvSpPr/>
+          <p:nvPr/>
+        </p:nvSpPr>
+        <p:spPr>
+          <a:xfrm>
+            <a:off x="914400" y="1920240"/>
+            <a:ext cx="3017520" cy="502920"/>
+          </a:xfrm>
+          <a:prstGeom prst="rect">
+            <a:avLst/>
+          </a:prstGeom>
+          <a:noFill/>
+          <a:ln/>
+        </p:spPr>
+        <p:txBody>
+          <a:bodyPr wrap="square" lIns="0" tIns="0" rIns="0" bIns="0" rtlCol="0" anchor="ctr"/>
+          <a:lstStyle/>
+          <a:p>
+            <a:pPr marL="0" indent="0">
+              <a:buNone/>
+            </a:pPr>
+            <a:r>
+              <a:rPr lang="en-US" sz="2400" b="1" dirty="0">
+                <a:solidFill>
+                  <a:srgbClr val="2C5F2D"/>
+                </a:solidFill>
+                <a:latin typeface="Cambria" pitchFamily="34" charset="0"/>
+                <a:ea typeface="Cambria" pitchFamily="34" charset="-122"/>
+                <a:cs typeface="Cambria" pitchFamily="34" charset="-120"/>
+              </a:rPr>
+              <a:t>Le symptôme</a:t>
+            </a:r>
+            <a:endParaRPr lang="en-US" sz="2400" dirty="0"/>
+          </a:p>
+        </p:txBody>
+      </p:sp>
+      <p:sp>
+        <p:nvSpPr>
+          <p:cNvPr id="6" name="Text 4"/>
+          <p:cNvSpPr/>
+          <p:nvPr/>
+        </p:nvSpPr>
+        <p:spPr>
+          <a:xfrm>
+            <a:off x="914400" y="2542032"/>
+            <a:ext cx="3017520" cy="1371600"/>
+          </a:xfrm>
+          <a:prstGeom prst="rect">
+            <a:avLst/>
+          </a:prstGeom>
+          <a:noFill/>
+          <a:ln/>
+        </p:spPr>
+        <p:txBody>
+          <a:bodyPr wrap="square" lIns="0" tIns="0" rIns="0" bIns="0" rtlCol="0" anchor="t"/>
+          <a:lstStyle/>
+          <a:p>
+            <a:pPr marL="0" indent="0">
+              <a:lnSpc>
+                <a:spcPct val="115000"/>
+              </a:lnSpc>
+              <a:buNone/>
+            </a:pPr>
+            <a:r>
+              <a:rPr lang="en-US" sz="1200" dirty="0">
+                <a:solidFill>
+                  <a:srgbClr val="1F2A1F"/>
+                </a:solidFill>
+                <a:latin typeface="Calibri" pitchFamily="34" charset="0"/>
+                <a:ea typeface="Calibri" pitchFamily="34" charset="-122"/>
+                <a:cs typeface="Calibri" pitchFamily="34" charset="-120"/>
+              </a:rPr>
+              <a:t>Un score de test trop beau, jamais retrouvé ensuite. Rien ne plante, rien n'avertit : le chiffre est simplement faux.</a:t>
+            </a:r>
+            <a:endParaRPr lang="en-US" sz="1200" dirty="0"/>
+          </a:p>
+        </p:txBody>
+      </p:sp>
+      <p:sp>
+        <p:nvSpPr>
+          <p:cNvPr id="7" name="Shape 5"/>
+          <p:cNvSpPr/>
+          <p:nvPr/>
+        </p:nvSpPr>
+        <p:spPr>
+          <a:xfrm>
+            <a:off x="4361688" y="1737360"/>
+            <a:ext cx="3538728" cy="2377440"/>
+          </a:xfrm>
+          <a:prstGeom prst="roundRect">
+            <a:avLst>
+              <a:gd name="adj" fmla="val 3077"/>
+            </a:avLst>
+          </a:prstGeom>
+          <a:solidFill>
+            <a:srgbClr val="EDF2E6"/>
+          </a:solidFill>
+          <a:ln w="12700">
+            <a:solidFill>
+              <a:srgbClr val="EDF2E6"/>
+            </a:solidFill>
+            <a:prstDash val="solid"/>
+          </a:ln>
+        </p:spPr>
+        <p:txBody>
+          <a:bodyPr/>
+          <a:lstStyle/>
+          <a:p>
+            <a:endParaRPr lang="en-US"/>
+          </a:p>
+        </p:txBody>
+      </p:sp>
+      <p:sp>
+        <p:nvSpPr>
+          <p:cNvPr id="8" name="Text 6"/>
+          <p:cNvSpPr/>
+          <p:nvPr/>
+        </p:nvSpPr>
+        <p:spPr>
+          <a:xfrm>
+            <a:off x="4636008" y="1920240"/>
+            <a:ext cx="3017520" cy="502920"/>
+          </a:xfrm>
+          <a:prstGeom prst="rect">
+            <a:avLst/>
+          </a:prstGeom>
+          <a:noFill/>
+          <a:ln/>
+        </p:spPr>
+        <p:txBody>
+          <a:bodyPr wrap="square" lIns="0" tIns="0" rIns="0" bIns="0" rtlCol="0" anchor="ctr"/>
+          <a:lstStyle/>
+          <a:p>
+            <a:pPr marL="0" indent="0">
+              <a:buNone/>
+            </a:pPr>
+            <a:r>
+              <a:rPr lang="en-US" sz="2400" b="1" dirty="0">
+                <a:solidFill>
+                  <a:srgbClr val="2C5F2D"/>
+                </a:solidFill>
+                <a:latin typeface="Cambria" pitchFamily="34" charset="0"/>
+                <a:ea typeface="Cambria" pitchFamily="34" charset="-122"/>
+                <a:cs typeface="Cambria" pitchFamily="34" charset="-120"/>
+              </a:rPr>
+              <a:t>La cause</a:t>
+            </a:r>
+            <a:endParaRPr lang="en-US" sz="2400" dirty="0"/>
+          </a:p>
+        </p:txBody>
+      </p:sp>
+      <p:sp>
+        <p:nvSpPr>
+          <p:cNvPr id="9" name="Text 7"/>
+          <p:cNvSpPr/>
+          <p:nvPr/>
+        </p:nvSpPr>
+        <p:spPr>
+          <a:xfrm>
+            <a:off x="4636008" y="2542032"/>
+            <a:ext cx="3017520" cy="1371600"/>
+          </a:xfrm>
+          <a:prstGeom prst="rect">
+            <a:avLst/>
+          </a:prstGeom>
+          <a:noFill/>
+          <a:ln/>
+        </p:spPr>
+        <p:txBody>
+          <a:bodyPr wrap="square" lIns="0" tIns="0" rIns="0" bIns="0" rtlCol="0" anchor="t"/>
+          <a:lstStyle/>
+          <a:p>
+            <a:pPr marL="0" indent="0">
+              <a:lnSpc>
+                <a:spcPct val="115000"/>
+              </a:lnSpc>
+              <a:buNone/>
+            </a:pPr>
+            <a:r>
+              <a:rPr lang="en-US" sz="1200" dirty="0">
+                <a:solidFill>
+                  <a:srgbClr val="1F2A1F"/>
+                </a:solidFill>
+                <a:latin typeface="Calibri" pitchFamily="34" charset="0"/>
+                <a:ea typeface="Calibri" pitchFamily="34" charset="-122"/>
+                <a:cs typeface="Calibri" pitchFamily="34" charset="-120"/>
+              </a:rPr>
+              <a:t>μ et σ calculés sur tout X avant le découpage. L'information du jeu de test entre dans la préparation, donc dans le modèle.</a:t>
+            </a:r>
+            <a:endParaRPr lang="en-US" sz="1200" dirty="0"/>
+          </a:p>
+        </p:txBody>
+      </p:sp>
+      <p:sp>
+        <p:nvSpPr>
+          <p:cNvPr id="10" name="Shape 8"/>
+          <p:cNvSpPr/>
+          <p:nvPr/>
+        </p:nvSpPr>
+        <p:spPr>
+          <a:xfrm>
+            <a:off x="8083296" y="1737360"/>
+            <a:ext cx="3538728" cy="2377440"/>
+          </a:xfrm>
+          <a:prstGeom prst="roundRect">
+            <a:avLst>
+              <a:gd name="adj" fmla="val 3077"/>
+            </a:avLst>
+          </a:prstGeom>
+          <a:solidFill>
+            <a:srgbClr val="EDF2E6"/>
+          </a:solidFill>
+          <a:ln w="12700">
+            <a:solidFill>
+              <a:srgbClr val="EDF2E6"/>
+            </a:solidFill>
+            <a:prstDash val="solid"/>
+          </a:ln>
+        </p:spPr>
+        <p:txBody>
+          <a:bodyPr/>
+          <a:lstStyle/>
+          <a:p>
+            <a:endParaRPr lang="en-US"/>
+          </a:p>
+        </p:txBody>
+      </p:sp>
+      <p:sp>
+        <p:nvSpPr>
+          <p:cNvPr id="11" name="Text 9"/>
+          <p:cNvSpPr/>
+          <p:nvPr/>
+        </p:nvSpPr>
+        <p:spPr>
+          <a:xfrm>
+            <a:off x="8357616" y="1920240"/>
+            <a:ext cx="3017520" cy="502920"/>
+          </a:xfrm>
+          <a:prstGeom prst="rect">
+            <a:avLst/>
+          </a:prstGeom>
+          <a:noFill/>
+          <a:ln/>
+        </p:spPr>
+        <p:txBody>
+          <a:bodyPr wrap="square" lIns="0" tIns="0" rIns="0" bIns="0" rtlCol="0" anchor="ctr"/>
+          <a:lstStyle/>
+          <a:p>
+            <a:pPr marL="0" indent="0">
+              <a:buNone/>
+            </a:pPr>
+            <a:r>
+              <a:rPr lang="en-US" sz="2400" b="1" dirty="0">
+                <a:solidFill>
+                  <a:srgbClr val="C0562F"/>
+                </a:solidFill>
+                <a:latin typeface="Cambria" pitchFamily="34" charset="0"/>
+                <a:ea typeface="Cambria" pitchFamily="34" charset="-122"/>
+                <a:cs typeface="Cambria" pitchFamily="34" charset="-120"/>
+              </a:rPr>
+              <a:t>Le remède</a:t>
+            </a:r>
+            <a:endParaRPr lang="en-US" sz="2400" dirty="0"/>
+          </a:p>
+        </p:txBody>
+      </p:sp>
+      <p:sp>
+        <p:nvSpPr>
+          <p:cNvPr id="12" name="Text 10"/>
+          <p:cNvSpPr/>
+          <p:nvPr/>
+        </p:nvSpPr>
+        <p:spPr>
+          <a:xfrm>
+            <a:off x="8357616" y="2542032"/>
+            <a:ext cx="3017520" cy="1371600"/>
+          </a:xfrm>
+          <a:prstGeom prst="rect">
+            <a:avLst/>
+          </a:prstGeom>
+          <a:noFill/>
+          <a:ln/>
+        </p:spPr>
+        <p:txBody>
+          <a:bodyPr wrap="square" lIns="0" tIns="0" rIns="0" bIns="0" rtlCol="0" anchor="t"/>
+          <a:lstStyle/>
+          <a:p>
+            <a:pPr marL="0" indent="0">
+              <a:lnSpc>
+                <a:spcPct val="115000"/>
+              </a:lnSpc>
+              <a:buNone/>
+            </a:pPr>
+            <a:r>
+              <a:rPr lang="en-US" sz="1200" dirty="0">
+                <a:solidFill>
+                  <a:srgbClr val="1F2A1F"/>
+                </a:solidFill>
+                <a:latin typeface="Calibri" pitchFamily="34" charset="0"/>
+                <a:ea typeface="Calibri" pitchFamily="34" charset="-122"/>
+                <a:cs typeface="Calibri" pitchFamily="34" charset="-120"/>
+              </a:rPr>
+              <a:t>Le pipeline : la préparation et l'estimateur deviennent un seul objet, qui s'ajuste d'un bloc sur le seul jeu d'entraînement.</a:t>
+            </a:r>
+            <a:endParaRPr lang="en-US" sz="1200" dirty="0"/>
+          </a:p>
+        </p:txBody>
+      </p:sp>
+      <p:sp>
+        <p:nvSpPr>
+          <p:cNvPr id="13" name="Shape 11"/>
+          <p:cNvSpPr/>
+          <p:nvPr/>
+        </p:nvSpPr>
+        <p:spPr>
+          <a:xfrm>
+            <a:off x="640080" y="4389120"/>
+            <a:ext cx="10881360" cy="1371600"/>
+          </a:xfrm>
+          <a:prstGeom prst="roundRect">
+            <a:avLst>
+              <a:gd name="adj" fmla="val 5333"/>
+            </a:avLst>
+          </a:prstGeom>
+          <a:solidFill>
+            <a:srgbClr val="1A3A1C"/>
+          </a:solidFill>
+          <a:ln w="12700">
+            <a:solidFill>
+              <a:srgbClr val="1A3A1C"/>
+            </a:solidFill>
+            <a:prstDash val="solid"/>
+          </a:ln>
+        </p:spPr>
+        <p:txBody>
+          <a:bodyPr/>
+          <a:lstStyle/>
+          <a:p>
+            <a:endParaRPr lang="en-US"/>
+          </a:p>
+        </p:txBody>
+      </p:sp>
+      <p:sp>
+        <p:nvSpPr>
+          <p:cNvPr id="14" name="Text 12"/>
+          <p:cNvSpPr/>
+          <p:nvPr/>
+        </p:nvSpPr>
+        <p:spPr>
+          <a:xfrm>
+            <a:off x="960120" y="4553712"/>
+            <a:ext cx="10241280" cy="320040"/>
+          </a:xfrm>
+          <a:prstGeom prst="rect">
+            <a:avLst/>
+          </a:prstGeom>
+          <a:noFill/>
+          <a:ln/>
+        </p:spPr>
+        <p:txBody>
+          <a:bodyPr wrap="square" lIns="0" tIns="0" rIns="0" bIns="0" rtlCol="0" anchor="ctr"/>
+          <a:lstStyle/>
+          <a:p>
+            <a:pPr marL="0" indent="0">
+              <a:buNone/>
+            </a:pPr>
+            <a:r>
+              <a:rPr lang="en-US" sz="1500" b="1" dirty="0">
+                <a:solidFill>
+                  <a:srgbClr val="97BC62"/>
+                </a:solidFill>
+                <a:latin typeface="Cambria" pitchFamily="34" charset="0"/>
+                <a:ea typeface="Cambria" pitchFamily="34" charset="-122"/>
+                <a:cs typeface="Cambria" pitchFamily="34" charset="-120"/>
+              </a:rPr>
+              <a:t>Séquentiel ou parallèle</a:t>
+            </a:r>
+            <a:endParaRPr lang="en-US" sz="1500" dirty="0"/>
+          </a:p>
+        </p:txBody>
+      </p:sp>
+      <p:sp>
+        <p:nvSpPr>
+          <p:cNvPr id="15" name="Text 13"/>
+          <p:cNvSpPr/>
+          <p:nvPr/>
+        </p:nvSpPr>
+        <p:spPr>
+          <a:xfrm>
+            <a:off x="960120" y="4937760"/>
+            <a:ext cx="10241280" cy="685800"/>
+          </a:xfrm>
+          <a:prstGeom prst="rect">
+            <a:avLst/>
+          </a:prstGeom>
+          <a:noFill/>
+          <a:ln/>
+        </p:spPr>
+        <p:txBody>
+          <a:bodyPr wrap="square" lIns="0" tIns="0" rIns="0" bIns="0" rtlCol="0" anchor="ctr"/>
+          <a:lstStyle/>
+          <a:p>
+            <a:pPr marL="0" indent="0">
+              <a:lnSpc>
+                <a:spcPct val="115000"/>
+              </a:lnSpc>
+              <a:buNone/>
+            </a:pPr>
+            <a:r>
+              <a:rPr lang="en-US" sz="1250" dirty="0">
+                <a:solidFill>
+                  <a:srgbClr val="FFFFFF"/>
+                </a:solidFill>
+                <a:latin typeface="Calibri" pitchFamily="34" charset="0"/>
+                <a:ea typeface="Calibri" pitchFamily="34" charset="-122"/>
+                <a:cs typeface="Calibri" pitchFamily="34" charset="-120"/>
+              </a:rPr>
+              <a:t>Pipeline enchaîne : la sortie d'une étape est l'entrée de la suivante. ColumnTransformer découpe : chaque branche ses colonnes, sorties concaténées. Une liste de paires (nom, objet) des deux côtés — ces noms préfixent les hyperparamètres.</a:t>
             </a:r>
             <a:endParaRPr lang="en-US" sz="1250" dirty="0"/>
           </a:p>

</xml_diff>